<commit_message>
add ref so bib is showing in document, fix presentation
</commit_message>
<xml_diff>
--- a/docs/presentation/Vizuálny transformer so sekundárnym vynorením.pptx
+++ b/docs/presentation/Vizuálny transformer so sekundárnym vynorením.pptx
@@ -5,19 +5,21 @@
     <p:sldMasterId id="2147483660" r:id="rId1"/>
   </p:sldMasterIdLst>
   <p:notesMasterIdLst>
-    <p:notesMasterId r:id="rId12"/>
+    <p:notesMasterId r:id="rId14"/>
   </p:notesMasterIdLst>
   <p:sldIdLst>
     <p:sldId id="256" r:id="rId2"/>
     <p:sldId id="257" r:id="rId3"/>
     <p:sldId id="258" r:id="rId4"/>
-    <p:sldId id="259" r:id="rId5"/>
-    <p:sldId id="260" r:id="rId6"/>
-    <p:sldId id="261" r:id="rId7"/>
-    <p:sldId id="263" r:id="rId8"/>
-    <p:sldId id="262" r:id="rId9"/>
-    <p:sldId id="264" r:id="rId10"/>
-    <p:sldId id="265" r:id="rId11"/>
+    <p:sldId id="267" r:id="rId5"/>
+    <p:sldId id="268" r:id="rId6"/>
+    <p:sldId id="260" r:id="rId7"/>
+    <p:sldId id="261" r:id="rId8"/>
+    <p:sldId id="263" r:id="rId9"/>
+    <p:sldId id="269" r:id="rId10"/>
+    <p:sldId id="262" r:id="rId11"/>
+    <p:sldId id="264" r:id="rId12"/>
+    <p:sldId id="265" r:id="rId13"/>
   </p:sldIdLst>
   <p:sldSz cx="12192000" cy="6858000"/>
   <p:notesSz cx="6858000" cy="9144000"/>
@@ -116,6 +118,11 @@
       </a:defRPr>
     </a:lvl9pPr>
   </p:defaultTextStyle>
+  <p:extLst>
+    <p:ext uri="{EFAFB233-063F-42B5-8137-9DF3F51BA10A}">
+      <p15:sldGuideLst xmlns:p15="http://schemas.microsoft.com/office/powerpoint/2012/main"/>
+    </p:ext>
+  </p:extLst>
 </p:presentation>
 </file>
 
@@ -469,90 +476,6 @@
 </p:notesMaster>
 </file>
 
-<file path=ppt/notesSlides/notesSlide1.xml><?xml version="1.0" encoding="utf-8"?>
-<p:notes xmlns:a="http://schemas.openxmlformats.org/drawingml/2006/main" xmlns:r="http://schemas.openxmlformats.org/officeDocument/2006/relationships" xmlns:p="http://schemas.openxmlformats.org/presentationml/2006/main">
-  <p:cSld>
-    <p:spTree>
-      <p:nvGrpSpPr>
-        <p:cNvPr id="1" name=""/>
-        <p:cNvGrpSpPr/>
-        <p:nvPr/>
-      </p:nvGrpSpPr>
-      <p:grpSpPr>
-        <a:xfrm>
-          <a:off x="0" y="0"/>
-          <a:ext cx="0" cy="0"/>
-          <a:chOff x="0" y="0"/>
-          <a:chExt cx="0" cy="0"/>
-        </a:xfrm>
-      </p:grpSpPr>
-      <p:sp>
-        <p:nvSpPr>
-          <p:cNvPr id="2" name="Slide Image Placeholder 1"/>
-          <p:cNvSpPr>
-            <a:spLocks noGrp="1" noRot="1" noChangeAspect="1"/>
-          </p:cNvSpPr>
-          <p:nvPr>
-            <p:ph type="sldImg"/>
-          </p:nvPr>
-        </p:nvSpPr>
-        <p:spPr/>
-      </p:sp>
-      <p:sp>
-        <p:nvSpPr>
-          <p:cNvPr id="3" name="Notes Placeholder 2"/>
-          <p:cNvSpPr>
-            <a:spLocks noGrp="1"/>
-          </p:cNvSpPr>
-          <p:nvPr>
-            <p:ph type="body" idx="1"/>
-          </p:nvPr>
-        </p:nvSpPr>
-        <p:spPr/>
-        <p:txBody>
-          <a:bodyPr/>
-          <a:lstStyle/>
-          <a:p>
-            <a:endParaRPr lang="sk-SK" dirty="0"/>
-          </a:p>
-        </p:txBody>
-      </p:sp>
-      <p:sp>
-        <p:nvSpPr>
-          <p:cNvPr id="4" name="Slide Number Placeholder 3"/>
-          <p:cNvSpPr>
-            <a:spLocks noGrp="1"/>
-          </p:cNvSpPr>
-          <p:nvPr>
-            <p:ph type="sldNum" sz="quarter" idx="5"/>
-          </p:nvPr>
-        </p:nvSpPr>
-        <p:spPr/>
-        <p:txBody>
-          <a:bodyPr/>
-          <a:lstStyle/>
-          <a:p>
-            <a:fld id="{686C4938-4780-45EB-B25A-DC64A95CFB45}" type="slidenum">
-              <a:rPr lang="sk-SK" smtClean="0"/>
-              <a:t>4</a:t>
-            </a:fld>
-            <a:endParaRPr lang="sk-SK"/>
-          </a:p>
-        </p:txBody>
-      </p:sp>
-    </p:spTree>
-    <p:extLst>
-      <p:ext uri="{BB962C8B-B14F-4D97-AF65-F5344CB8AC3E}">
-        <p14:creationId xmlns:p14="http://schemas.microsoft.com/office/powerpoint/2010/main" val="1403998130"/>
-      </p:ext>
-    </p:extLst>
-  </p:cSld>
-  <p:clrMapOvr>
-    <a:masterClrMapping/>
-  </p:clrMapOvr>
-</p:notes>
-</file>
-
 <file path=ppt/slideLayouts/slideLayout1.xml><?xml version="1.0" encoding="utf-8"?>
 <p:sldLayout xmlns:a="http://schemas.openxmlformats.org/drawingml/2006/main" xmlns:r="http://schemas.openxmlformats.org/officeDocument/2006/relationships" xmlns:p="http://schemas.openxmlformats.org/presentationml/2006/main" showMasterSp="0" type="title" preserve="1">
   <p:cSld name="Title Slide">
@@ -607,6 +530,13 @@
             <a:schemeClr val="lt1"/>
           </a:fontRef>
         </p:style>
+        <p:txBody>
+          <a:bodyPr/>
+          <a:lstStyle/>
+          <a:p>
+            <a:endParaRPr lang="sk-SK"/>
+          </a:p>
+        </p:txBody>
       </p:sp>
       <p:sp>
         <p:nvSpPr>
@@ -645,6 +575,13 @@
             <a:schemeClr val="lt1"/>
           </a:fontRef>
         </p:style>
+        <p:txBody>
+          <a:bodyPr/>
+          <a:lstStyle/>
+          <a:p>
+            <a:endParaRPr lang="sk-SK"/>
+          </a:p>
+        </p:txBody>
       </p:sp>
       <p:sp>
         <p:nvSpPr>
@@ -3559,6 +3496,13 @@
             <a:schemeClr val="lt1"/>
           </a:fontRef>
         </p:style>
+        <p:txBody>
+          <a:bodyPr/>
+          <a:lstStyle/>
+          <a:p>
+            <a:endParaRPr lang="sk-SK"/>
+          </a:p>
+        </p:txBody>
       </p:sp>
       <p:sp>
         <p:nvSpPr>
@@ -3597,6 +3541,13 @@
             <a:schemeClr val="lt1"/>
           </a:fontRef>
         </p:style>
+        <p:txBody>
+          <a:bodyPr/>
+          <a:lstStyle/>
+          <a:p>
+            <a:endParaRPr lang="sk-SK"/>
+          </a:p>
+        </p:txBody>
       </p:sp>
       <p:sp>
         <p:nvSpPr>
@@ -4511,7 +4462,7 @@
                 </a:solidFill>
                 <a:latin typeface="+mn-lt"/>
               </a:rPr>
-              <a:t>Miškovčík</a:t>
+              <a:t>Miškovčík		Školiteľ: RNDr. Andrej Lúčny, PhD.</a:t>
             </a:r>
             <a:br>
               <a:rPr lang="sk-SK" dirty="0">
@@ -4630,6 +4581,570 @@
           <p:cNvPr id="2" name="Title 1">
             <a:extLst>
               <a:ext uri="{FF2B5EF4-FFF2-40B4-BE49-F238E27FC236}">
+                <a16:creationId xmlns:a16="http://schemas.microsoft.com/office/drawing/2014/main" id="{7B1EF07C-36D6-BC87-4879-9FE32ACE4AD8}"/>
+              </a:ext>
+            </a:extLst>
+          </p:cNvPr>
+          <p:cNvSpPr>
+            <a:spLocks noGrp="1"/>
+          </p:cNvSpPr>
+          <p:nvPr>
+            <p:ph type="title"/>
+          </p:nvPr>
+        </p:nvSpPr>
+        <p:spPr/>
+        <p:txBody>
+          <a:bodyPr/>
+          <a:lstStyle/>
+          <a:p>
+            <a:r>
+              <a:rPr lang="sk-SK" dirty="0" err="1"/>
+              <a:t>Framework</a:t>
+            </a:r>
+            <a:r>
+              <a:rPr lang="sk-SK" dirty="0"/>
+              <a:t> test</a:t>
+            </a:r>
+          </a:p>
+        </p:txBody>
+      </p:sp>
+      <p:sp>
+        <p:nvSpPr>
+          <p:cNvPr id="3" name="Content Placeholder 2">
+            <a:extLst>
+              <a:ext uri="{FF2B5EF4-FFF2-40B4-BE49-F238E27FC236}">
+                <a16:creationId xmlns:a16="http://schemas.microsoft.com/office/drawing/2014/main" id="{252866B2-1E9F-B79C-8561-B0091217EFA4}"/>
+              </a:ext>
+            </a:extLst>
+          </p:cNvPr>
+          <p:cNvSpPr>
+            <a:spLocks noGrp="1"/>
+          </p:cNvSpPr>
+          <p:nvPr>
+            <p:ph idx="1"/>
+          </p:nvPr>
+        </p:nvSpPr>
+        <p:spPr/>
+        <p:txBody>
+          <a:bodyPr/>
+          <a:lstStyle/>
+          <a:p>
+            <a:r>
+              <a:rPr lang="sk-SK" dirty="0"/>
+              <a:t>V mojom teste je použitý </a:t>
+            </a:r>
+            <a:r>
+              <a:rPr lang="sk-SK" dirty="0" err="1"/>
+              <a:t>predtrénovaný</a:t>
+            </a:r>
+            <a:r>
+              <a:rPr lang="sk-SK" dirty="0"/>
+              <a:t> </a:t>
+            </a:r>
+            <a:r>
+              <a:rPr lang="sk-SK" dirty="0" err="1"/>
+              <a:t>Vision</a:t>
+            </a:r>
+            <a:r>
+              <a:rPr lang="sk-SK" dirty="0"/>
+              <a:t> </a:t>
+            </a:r>
+            <a:r>
+              <a:rPr lang="sk-SK" dirty="0" err="1"/>
+              <a:t>Transformer</a:t>
+            </a:r>
+            <a:r>
+              <a:rPr lang="sk-SK" dirty="0"/>
+              <a:t> vit_b_16 z knižnice </a:t>
+            </a:r>
+            <a:r>
+              <a:rPr lang="sk-SK" dirty="0" err="1"/>
+              <a:t>torchvision</a:t>
+            </a:r>
+            <a:r>
+              <a:rPr lang="sk-SK" dirty="0"/>
+              <a:t>.</a:t>
+            </a:r>
+            <a:br>
+              <a:rPr lang="sk-SK" dirty="0"/>
+            </a:br>
+            <a:r>
+              <a:rPr lang="sk-SK" dirty="0"/>
+              <a:t>Cieľom je overiť načítanie modelu, predspracovanie vstupného obrázka a získanie výstupných pravdepodobností tried.</a:t>
+            </a:r>
+          </a:p>
+          <a:p>
+            <a:endParaRPr lang="sk-SK" dirty="0"/>
+          </a:p>
+        </p:txBody>
+      </p:sp>
+      <p:pic>
+        <p:nvPicPr>
+          <p:cNvPr id="9" name="Picture 8">
+            <a:extLst>
+              <a:ext uri="{FF2B5EF4-FFF2-40B4-BE49-F238E27FC236}">
+                <a16:creationId xmlns:a16="http://schemas.microsoft.com/office/drawing/2014/main" id="{2453C978-CEB6-C737-7668-FAE005FA9ACE}"/>
+              </a:ext>
+            </a:extLst>
+          </p:cNvPr>
+          <p:cNvPicPr>
+            <a:picLocks noChangeAspect="1"/>
+          </p:cNvPicPr>
+          <p:nvPr/>
+        </p:nvPicPr>
+        <p:blipFill>
+          <a:blip r:embed="rId2"/>
+          <a:stretch>
+            <a:fillRect/>
+          </a:stretch>
+        </p:blipFill>
+        <p:spPr>
+          <a:xfrm>
+            <a:off x="1097280" y="2746094"/>
+            <a:ext cx="4551103" cy="3478192"/>
+          </a:xfrm>
+          <a:prstGeom prst="rect">
+            <a:avLst/>
+          </a:prstGeom>
+        </p:spPr>
+      </p:pic>
+      <p:pic>
+        <p:nvPicPr>
+          <p:cNvPr id="11" name="Picture 10">
+            <a:extLst>
+              <a:ext uri="{FF2B5EF4-FFF2-40B4-BE49-F238E27FC236}">
+                <a16:creationId xmlns:a16="http://schemas.microsoft.com/office/drawing/2014/main" id="{E67D4B07-56A4-806D-8F09-6E106BB28963}"/>
+              </a:ext>
+            </a:extLst>
+          </p:cNvPr>
+          <p:cNvPicPr>
+            <a:picLocks noChangeAspect="1"/>
+          </p:cNvPicPr>
+          <p:nvPr/>
+        </p:nvPicPr>
+        <p:blipFill>
+          <a:blip r:embed="rId3"/>
+          <a:stretch>
+            <a:fillRect/>
+          </a:stretch>
+        </p:blipFill>
+        <p:spPr>
+          <a:xfrm>
+            <a:off x="5690824" y="2746094"/>
+            <a:ext cx="4219437" cy="2138422"/>
+          </a:xfrm>
+          <a:prstGeom prst="rect">
+            <a:avLst/>
+          </a:prstGeom>
+        </p:spPr>
+      </p:pic>
+    </p:spTree>
+    <p:extLst>
+      <p:ext uri="{BB962C8B-B14F-4D97-AF65-F5344CB8AC3E}">
+        <p14:creationId xmlns:p14="http://schemas.microsoft.com/office/powerpoint/2010/main" val="2086404062"/>
+      </p:ext>
+    </p:extLst>
+  </p:cSld>
+  <p:clrMapOvr>
+    <a:masterClrMapping/>
+  </p:clrMapOvr>
+</p:sld>
+</file>
+
+<file path=ppt/slides/slide11.xml><?xml version="1.0" encoding="utf-8"?>
+<p:sld xmlns:a="http://schemas.openxmlformats.org/drawingml/2006/main" xmlns:r="http://schemas.openxmlformats.org/officeDocument/2006/relationships" xmlns:p="http://schemas.openxmlformats.org/presentationml/2006/main">
+  <p:cSld>
+    <p:bg>
+      <p:bgPr>
+        <a:solidFill>
+          <a:schemeClr val="bg1"/>
+        </a:solidFill>
+        <a:effectLst/>
+      </p:bgPr>
+    </p:bg>
+    <p:spTree>
+      <p:nvGrpSpPr>
+        <p:cNvPr id="1" name=""/>
+        <p:cNvGrpSpPr/>
+        <p:nvPr/>
+      </p:nvGrpSpPr>
+      <p:grpSpPr>
+        <a:xfrm>
+          <a:off x="0" y="0"/>
+          <a:ext cx="0" cy="0"/>
+          <a:chOff x="0" y="0"/>
+          <a:chExt cx="0" cy="0"/>
+        </a:xfrm>
+      </p:grpSpPr>
+      <p:sp useBgFill="1">
+        <p:nvSpPr>
+          <p:cNvPr id="17" name="Rectangle 16">
+            <a:extLst>
+              <a:ext uri="{FF2B5EF4-FFF2-40B4-BE49-F238E27FC236}">
+                <a16:creationId xmlns:a16="http://schemas.microsoft.com/office/drawing/2014/main" id="{3741B58E-3B65-4A01-A276-975AB2CF8A08}"/>
+              </a:ext>
+              <a:ext uri="{C183D7F6-B498-43B3-948B-1728B52AA6E4}">
+                <adec:decorative xmlns:adec="http://schemas.microsoft.com/office/drawing/2017/decorative" val="1"/>
+              </a:ext>
+            </a:extLst>
+          </p:cNvPr>
+          <p:cNvSpPr>
+            <a:spLocks noGrp="1" noRot="1" noChangeAspect="1" noMove="1" noResize="1" noEditPoints="1" noAdjustHandles="1" noChangeArrowheads="1" noChangeShapeType="1" noTextEdit="1"/>
+          </p:cNvSpPr>
+          <p:nvPr>
+            <p:extLst>
+              <p:ext uri="{386F3935-93C4-4BCD-93E2-E3B085C9AB24}">
+                <p16:designElem xmlns:p16="http://schemas.microsoft.com/office/powerpoint/2015/main" val="1"/>
+              </p:ext>
+            </p:extLst>
+          </p:nvPr>
+        </p:nvSpPr>
+        <p:spPr>
+          <a:xfrm>
+            <a:off x="0" y="0"/>
+            <a:ext cx="12186315" cy="6858000"/>
+          </a:xfrm>
+          <a:prstGeom prst="rect">
+            <a:avLst/>
+          </a:prstGeom>
+          <a:ln>
+            <a:noFill/>
+          </a:ln>
+        </p:spPr>
+        <p:style>
+          <a:lnRef idx="2">
+            <a:schemeClr val="accent6">
+              <a:shade val="50000"/>
+            </a:schemeClr>
+          </a:lnRef>
+          <a:fillRef idx="1001">
+            <a:schemeClr val="lt1"/>
+          </a:fillRef>
+          <a:effectRef idx="0">
+            <a:schemeClr val="accent6"/>
+          </a:effectRef>
+          <a:fontRef idx="minor">
+            <a:schemeClr val="lt1"/>
+          </a:fontRef>
+        </p:style>
+        <p:txBody>
+          <a:bodyPr rtlCol="0" anchor="ctr"/>
+          <a:lstStyle/>
+          <a:p>
+            <a:pPr algn="ctr"/>
+            <a:endParaRPr lang="en-US"/>
+          </a:p>
+        </p:txBody>
+      </p:sp>
+      <p:sp>
+        <p:nvSpPr>
+          <p:cNvPr id="19" name="Rectangle 18">
+            <a:extLst>
+              <a:ext uri="{FF2B5EF4-FFF2-40B4-BE49-F238E27FC236}">
+                <a16:creationId xmlns:a16="http://schemas.microsoft.com/office/drawing/2014/main" id="{7AAC67C3-831B-4AB1-A259-DFB839CAFAFC}"/>
+              </a:ext>
+              <a:ext uri="{C183D7F6-B498-43B3-948B-1728B52AA6E4}">
+                <adec:decorative xmlns:adec="http://schemas.microsoft.com/office/drawing/2017/decorative" val="1"/>
+              </a:ext>
+            </a:extLst>
+          </p:cNvPr>
+          <p:cNvSpPr>
+            <a:spLocks noGrp="1" noRot="1" noChangeAspect="1" noMove="1" noResize="1" noEditPoints="1" noAdjustHandles="1" noChangeArrowheads="1" noChangeShapeType="1" noTextEdit="1"/>
+          </p:cNvSpPr>
+          <p:nvPr>
+            <p:extLst>
+              <p:ext uri="{386F3935-93C4-4BCD-93E2-E3B085C9AB24}">
+                <p16:designElem xmlns:p16="http://schemas.microsoft.com/office/powerpoint/2015/main" val="1"/>
+              </p:ext>
+            </p:extLst>
+          </p:nvPr>
+        </p:nvSpPr>
+        <p:spPr>
+          <a:xfrm>
+            <a:off x="16" y="0"/>
+            <a:ext cx="4050791" cy="6858000"/>
+          </a:xfrm>
+          <a:prstGeom prst="rect">
+            <a:avLst/>
+          </a:prstGeom>
+          <a:solidFill>
+            <a:schemeClr val="accent2"/>
+          </a:solidFill>
+          <a:ln>
+            <a:noFill/>
+          </a:ln>
+        </p:spPr>
+        <p:style>
+          <a:lnRef idx="2">
+            <a:schemeClr val="accent1">
+              <a:shade val="50000"/>
+            </a:schemeClr>
+          </a:lnRef>
+          <a:fillRef idx="1">
+            <a:schemeClr val="accent1"/>
+          </a:fillRef>
+          <a:effectRef idx="0">
+            <a:schemeClr val="accent1"/>
+          </a:effectRef>
+          <a:fontRef idx="minor">
+            <a:schemeClr val="lt1"/>
+          </a:fontRef>
+        </p:style>
+        <p:txBody>
+          <a:bodyPr/>
+          <a:lstStyle/>
+          <a:p>
+            <a:endParaRPr lang="sk-SK"/>
+          </a:p>
+        </p:txBody>
+      </p:sp>
+      <p:sp>
+        <p:nvSpPr>
+          <p:cNvPr id="2" name="Title 1">
+            <a:extLst>
+              <a:ext uri="{FF2B5EF4-FFF2-40B4-BE49-F238E27FC236}">
+                <a16:creationId xmlns:a16="http://schemas.microsoft.com/office/drawing/2014/main" id="{D140E1EE-5857-4344-5F2B-F49DA8C5646A}"/>
+              </a:ext>
+            </a:extLst>
+          </p:cNvPr>
+          <p:cNvSpPr>
+            <a:spLocks noGrp="1"/>
+          </p:cNvSpPr>
+          <p:nvPr>
+            <p:ph type="title"/>
+          </p:nvPr>
+        </p:nvSpPr>
+        <p:spPr>
+          <a:xfrm>
+            <a:off x="492370" y="605896"/>
+            <a:ext cx="3084844" cy="5646208"/>
+          </a:xfrm>
+        </p:spPr>
+        <p:txBody>
+          <a:bodyPr anchor="ctr">
+            <a:normAutofit/>
+          </a:bodyPr>
+          <a:lstStyle/>
+          <a:p>
+            <a:r>
+              <a:rPr lang="sk-SK" sz="3600">
+                <a:solidFill>
+                  <a:srgbClr val="FFFFFF"/>
+                </a:solidFill>
+              </a:rPr>
+              <a:t>Plán ďalšej práce</a:t>
+            </a:r>
+          </a:p>
+        </p:txBody>
+      </p:sp>
+      <p:sp>
+        <p:nvSpPr>
+          <p:cNvPr id="21" name="Rectangle 20">
+            <a:extLst>
+              <a:ext uri="{FF2B5EF4-FFF2-40B4-BE49-F238E27FC236}">
+                <a16:creationId xmlns:a16="http://schemas.microsoft.com/office/drawing/2014/main" id="{054B3F04-9EAC-45C0-B3CE-0387EEA10A0C}"/>
+              </a:ext>
+              <a:ext uri="{C183D7F6-B498-43B3-948B-1728B52AA6E4}">
+                <adec:decorative xmlns:adec="http://schemas.microsoft.com/office/drawing/2017/decorative" val="1"/>
+              </a:ext>
+            </a:extLst>
+          </p:cNvPr>
+          <p:cNvSpPr>
+            <a:spLocks noGrp="1" noRot="1" noChangeAspect="1" noMove="1" noResize="1" noEditPoints="1" noAdjustHandles="1" noChangeArrowheads="1" noChangeShapeType="1" noTextEdit="1"/>
+          </p:cNvSpPr>
+          <p:nvPr>
+            <p:extLst>
+              <p:ext uri="{386F3935-93C4-4BCD-93E2-E3B085C9AB24}">
+                <p16:designElem xmlns:p16="http://schemas.microsoft.com/office/powerpoint/2015/main" val="1"/>
+              </p:ext>
+            </p:extLst>
+          </p:nvPr>
+        </p:nvSpPr>
+        <p:spPr>
+          <a:xfrm>
+            <a:off x="4040071" y="0"/>
+            <a:ext cx="64008" cy="6858000"/>
+          </a:xfrm>
+          <a:prstGeom prst="rect">
+            <a:avLst/>
+          </a:prstGeom>
+          <a:solidFill>
+            <a:schemeClr val="accent1"/>
+          </a:solidFill>
+          <a:ln>
+            <a:noFill/>
+          </a:ln>
+        </p:spPr>
+        <p:style>
+          <a:lnRef idx="2">
+            <a:schemeClr val="accent1">
+              <a:shade val="50000"/>
+            </a:schemeClr>
+          </a:lnRef>
+          <a:fillRef idx="1">
+            <a:schemeClr val="accent1"/>
+          </a:fillRef>
+          <a:effectRef idx="0">
+            <a:schemeClr val="accent1"/>
+          </a:effectRef>
+          <a:fontRef idx="minor">
+            <a:schemeClr val="lt1"/>
+          </a:fontRef>
+        </p:style>
+        <p:txBody>
+          <a:bodyPr/>
+          <a:lstStyle/>
+          <a:p>
+            <a:endParaRPr lang="sk-SK"/>
+          </a:p>
+        </p:txBody>
+      </p:sp>
+      <p:sp>
+        <p:nvSpPr>
+          <p:cNvPr id="3" name="Content Placeholder 2">
+            <a:extLst>
+              <a:ext uri="{FF2B5EF4-FFF2-40B4-BE49-F238E27FC236}">
+                <a16:creationId xmlns:a16="http://schemas.microsoft.com/office/drawing/2014/main" id="{D671BE1D-4FE4-18E9-93AD-8D9CB704EECA}"/>
+              </a:ext>
+            </a:extLst>
+          </p:cNvPr>
+          <p:cNvSpPr>
+            <a:spLocks noGrp="1"/>
+          </p:cNvSpPr>
+          <p:nvPr>
+            <p:ph idx="1"/>
+          </p:nvPr>
+        </p:nvSpPr>
+        <p:spPr>
+          <a:xfrm>
+            <a:off x="4742016" y="605896"/>
+            <a:ext cx="6413663" cy="5646208"/>
+          </a:xfrm>
+        </p:spPr>
+        <p:txBody>
+          <a:bodyPr anchor="ctr">
+            <a:normAutofit/>
+          </a:bodyPr>
+          <a:lstStyle/>
+          <a:p>
+            <a:pPr>
+              <a:buFont typeface="Arial" panose="020B0604020202020204" pitchFamily="34" charset="0"/>
+              <a:buChar char="•"/>
+            </a:pPr>
+            <a:r>
+              <a:rPr lang="sk-SK" dirty="0"/>
+              <a:t> implementácia </a:t>
+            </a:r>
+            <a:r>
+              <a:rPr lang="sk-SK" dirty="0" err="1"/>
+              <a:t>ViT</a:t>
+            </a:r>
+            <a:r>
+              <a:rPr lang="sk-SK" dirty="0"/>
+              <a:t> s klasickým vynorením</a:t>
+            </a:r>
+          </a:p>
+          <a:p>
+            <a:pPr>
+              <a:buFont typeface="Arial" panose="020B0604020202020204" pitchFamily="34" charset="0"/>
+              <a:buChar char="•"/>
+            </a:pPr>
+            <a:r>
+              <a:rPr lang="sk-SK" dirty="0"/>
+              <a:t> Implementácia </a:t>
+            </a:r>
+            <a:r>
+              <a:rPr lang="sk-SK" dirty="0" err="1"/>
+              <a:t>ViT</a:t>
+            </a:r>
+            <a:r>
+              <a:rPr lang="sk-SK" dirty="0"/>
+              <a:t> s hlavou</a:t>
+            </a:r>
+          </a:p>
+          <a:p>
+            <a:pPr>
+              <a:buFont typeface="Arial" panose="020B0604020202020204" pitchFamily="34" charset="0"/>
+              <a:buChar char="•"/>
+            </a:pPr>
+            <a:r>
+              <a:rPr lang="sk-SK" dirty="0"/>
+              <a:t> implementácia </a:t>
+            </a:r>
+            <a:r>
+              <a:rPr lang="sk-SK" dirty="0" err="1"/>
+              <a:t>ViT</a:t>
+            </a:r>
+            <a:r>
+              <a:rPr lang="sk-SK" dirty="0"/>
+              <a:t> s </a:t>
+            </a:r>
+            <a:r>
+              <a:rPr lang="sk-SK" dirty="0" err="1"/>
+              <a:t>viacvektorovým</a:t>
+            </a:r>
+            <a:r>
+              <a:rPr lang="sk-SK" dirty="0"/>
+              <a:t> vynorením</a:t>
+            </a:r>
+          </a:p>
+          <a:p>
+            <a:pPr>
+              <a:buFont typeface="Arial" panose="020B0604020202020204" pitchFamily="34" charset="0"/>
+              <a:buChar char="•"/>
+            </a:pPr>
+            <a:r>
+              <a:rPr lang="sk-SK" dirty="0"/>
+              <a:t> návrh experimentov</a:t>
+            </a:r>
+          </a:p>
+          <a:p>
+            <a:pPr>
+              <a:buFont typeface="Arial" panose="020B0604020202020204" pitchFamily="34" charset="0"/>
+              <a:buChar char="•"/>
+            </a:pPr>
+            <a:r>
+              <a:rPr lang="sk-SK" dirty="0"/>
+              <a:t> vyhodnotenie výsledkov</a:t>
+            </a:r>
+          </a:p>
+        </p:txBody>
+      </p:sp>
+    </p:spTree>
+    <p:extLst>
+      <p:ext uri="{BB962C8B-B14F-4D97-AF65-F5344CB8AC3E}">
+        <p14:creationId xmlns:p14="http://schemas.microsoft.com/office/powerpoint/2010/main" val="2473980231"/>
+      </p:ext>
+    </p:extLst>
+  </p:cSld>
+  <p:clrMapOvr>
+    <a:masterClrMapping/>
+  </p:clrMapOvr>
+</p:sld>
+</file>
+
+<file path=ppt/slides/slide12.xml><?xml version="1.0" encoding="utf-8"?>
+<p:sld xmlns:a="http://schemas.openxmlformats.org/drawingml/2006/main" xmlns:r="http://schemas.openxmlformats.org/officeDocument/2006/relationships" xmlns:p="http://schemas.openxmlformats.org/presentationml/2006/main">
+  <p:cSld>
+    <p:spTree>
+      <p:nvGrpSpPr>
+        <p:cNvPr id="1" name=""/>
+        <p:cNvGrpSpPr/>
+        <p:nvPr/>
+      </p:nvGrpSpPr>
+      <p:grpSpPr>
+        <a:xfrm>
+          <a:off x="0" y="0"/>
+          <a:ext cx="0" cy="0"/>
+          <a:chOff x="0" y="0"/>
+          <a:chExt cx="0" cy="0"/>
+        </a:xfrm>
+      </p:grpSpPr>
+      <p:sp>
+        <p:nvSpPr>
+          <p:cNvPr id="2" name="Title 1">
+            <a:extLst>
+              <a:ext uri="{FF2B5EF4-FFF2-40B4-BE49-F238E27FC236}">
                 <a16:creationId xmlns:a16="http://schemas.microsoft.com/office/drawing/2014/main" id="{E966BAF9-4B36-A559-AFB1-EF0D7CE493C2}"/>
               </a:ext>
             </a:extLst>
@@ -4650,31 +5165,6 @@
               <a:rPr lang="sk-SK" dirty="0"/>
               <a:t>Ďakujem za pozornosť</a:t>
             </a:r>
-          </a:p>
-        </p:txBody>
-      </p:sp>
-      <p:sp>
-        <p:nvSpPr>
-          <p:cNvPr id="3" name="Content Placeholder 2">
-            <a:extLst>
-              <a:ext uri="{FF2B5EF4-FFF2-40B4-BE49-F238E27FC236}">
-                <a16:creationId xmlns:a16="http://schemas.microsoft.com/office/drawing/2014/main" id="{E7B45C3B-A19F-A234-64F4-21E3B8B6B4EA}"/>
-              </a:ext>
-            </a:extLst>
-          </p:cNvPr>
-          <p:cNvSpPr>
-            <a:spLocks noGrp="1"/>
-          </p:cNvSpPr>
-          <p:nvPr>
-            <p:ph idx="1"/>
-          </p:nvPr>
-        </p:nvSpPr>
-        <p:spPr/>
-        <p:txBody>
-          <a:bodyPr/>
-          <a:lstStyle/>
-          <a:p>
-            <a:endParaRPr lang="sk-SK"/>
           </a:p>
         </p:txBody>
       </p:sp>
@@ -4867,7 +5357,7 @@
           <a:lstStyle/>
           <a:p>
             <a:r>
-              <a:rPr lang="sk-SK" sz="3600">
+              <a:rPr lang="sk-SK" sz="3600" dirty="0">
                 <a:solidFill>
                   <a:srgbClr val="FFFFFF"/>
                 </a:solidFill>
@@ -4958,7 +5448,7 @@
         <p:spPr>
           <a:xfrm>
             <a:off x="4742016" y="605896"/>
-            <a:ext cx="6413663" cy="5646208"/>
+            <a:ext cx="6860049" cy="5646208"/>
           </a:xfrm>
         </p:spPr>
         <p:txBody>
@@ -4967,58 +5457,129 @@
           </a:bodyPr>
           <a:lstStyle/>
           <a:p>
+            <a:pPr>
+              <a:buFont typeface="Arial" panose="020B0604020202020204" pitchFamily="34" charset="0"/>
+              <a:buChar char="•"/>
+            </a:pPr>
             <a:r>
               <a:rPr lang="sk-SK" dirty="0"/>
-              <a:t>- </a:t>
+              <a:t> Vizuálny </a:t>
             </a:r>
             <a:r>
               <a:rPr lang="sk-SK" dirty="0" err="1"/>
-              <a:t>Vision</a:t>
+              <a:t>transformer</a:t>
             </a:r>
             <a:r>
               <a:rPr lang="sk-SK" dirty="0"/>
+              <a:t> patrí medzi moderné modely pre klasifikáciu obrazu</a:t>
+            </a:r>
+          </a:p>
+          <a:p>
+            <a:pPr>
+              <a:buFont typeface="Arial" panose="020B0604020202020204" pitchFamily="34" charset="0"/>
+              <a:buChar char="•"/>
+            </a:pPr>
+            <a:r>
+              <a:rPr lang="sk-SK" dirty="0"/>
+              <a:t> Zakončený môže byť:</a:t>
+            </a:r>
+          </a:p>
+          <a:p>
+            <a:pPr lvl="1">
+              <a:buFont typeface="Arial" panose="020B0604020202020204" pitchFamily="34" charset="0"/>
+              <a:buChar char="•"/>
+            </a:pPr>
+            <a:r>
+              <a:rPr lang="sk-SK" sz="2000" dirty="0"/>
+              <a:t>Vynorením – výstup </a:t>
+            </a:r>
+            <a:r>
+              <a:rPr lang="en-US" sz="2000" dirty="0"/>
+              <a:t>(CLS token)</a:t>
+            </a:r>
+            <a:r>
+              <a:rPr lang="sk-SK" sz="2000" dirty="0"/>
+              <a:t> sa porovnáva s </a:t>
+            </a:r>
+            <a:r>
+              <a:rPr lang="sk-SK" sz="2000" dirty="0" err="1"/>
+              <a:t>embedding</a:t>
+            </a:r>
+            <a:r>
+              <a:rPr lang="sk-SK" sz="2000" dirty="0"/>
+              <a:t> vektormi kategórií</a:t>
+            </a:r>
+          </a:p>
+          <a:p>
+            <a:pPr lvl="1">
+              <a:buFont typeface="Arial" panose="020B0604020202020204" pitchFamily="34" charset="0"/>
+              <a:buChar char="•"/>
+            </a:pPr>
+            <a:r>
+              <a:rPr lang="sk-SK" sz="2000" dirty="0"/>
+              <a:t>Hlavou – </a:t>
+            </a:r>
+            <a:r>
+              <a:rPr lang="sk-SK" sz="2000" dirty="0" err="1"/>
+              <a:t>perceptron</a:t>
+            </a:r>
+            <a:r>
+              <a:rPr lang="sk-SK" sz="2000" dirty="0"/>
+              <a:t> z CLS tokenu počíta log</a:t>
+            </a:r>
+            <a:r>
+              <a:rPr lang="en-US" sz="2000" dirty="0" err="1"/>
+              <a:t>aritmy</a:t>
+            </a:r>
+            <a:r>
+              <a:rPr lang="en-US" sz="2000" dirty="0"/>
               <a:t> </a:t>
             </a:r>
             <a:r>
+              <a:rPr lang="en-US" sz="2000" dirty="0" err="1"/>
+              <a:t>pravdepodobnost</a:t>
+            </a:r>
+            <a:r>
+              <a:rPr lang="sk-SK" sz="2000" dirty="0"/>
+              <a:t>í</a:t>
+            </a:r>
+          </a:p>
+          <a:p>
+            <a:pPr>
+              <a:buFont typeface="Arial" panose="020B0604020202020204" pitchFamily="34" charset="0"/>
+              <a:buChar char="•"/>
+            </a:pPr>
+            <a:r>
+              <a:rPr lang="sk-SK" dirty="0"/>
+              <a:t> Pri klasickom vynorení je kategória reprezentovaná jedným vektorom</a:t>
+            </a:r>
+          </a:p>
+          <a:p>
+            <a:pPr>
+              <a:buFont typeface="Arial" panose="020B0604020202020204" pitchFamily="34" charset="0"/>
+              <a:buChar char="•"/>
+            </a:pPr>
+            <a:r>
+              <a:rPr lang="sk-SK" dirty="0"/>
+              <a:t> Práca skúma rozšírenie: kategória reprezentovaná viacerými vektormi</a:t>
+            </a:r>
+          </a:p>
+          <a:p>
+            <a:pPr>
+              <a:buFont typeface="Arial" panose="020B0604020202020204" pitchFamily="34" charset="0"/>
+              <a:buChar char="•"/>
+            </a:pPr>
+            <a:r>
+              <a:rPr lang="sk-SK" dirty="0"/>
+              <a:t> Cieľom je overiť, či </a:t>
+            </a:r>
+            <a:r>
               <a:rPr lang="sk-SK" dirty="0" err="1"/>
-              <a:t>Transformery</a:t>
+              <a:t>viacvektorová</a:t>
             </a:r>
             <a:r>
               <a:rPr lang="sk-SK" dirty="0"/>
-              <a:t> patria medzi moderné modely pre klasifikáciu obrazu</a:t>
-            </a:r>
-            <a:br>
-              <a:rPr lang="sk-SK" dirty="0"/>
-            </a:br>
-            <a:r>
-              <a:rPr lang="sk-SK" dirty="0"/>
-              <a:t>- Klasifikácia sa štandardne realizuje pomocou MLP </a:t>
-            </a:r>
-            <a:r>
-              <a:rPr lang="sk-SK" dirty="0" err="1"/>
-              <a:t>head</a:t>
-            </a:r>
-            <a:r>
-              <a:rPr lang="sk-SK" dirty="0"/>
-              <a:t> prístupu</a:t>
-            </a:r>
-            <a:br>
-              <a:rPr lang="sk-SK" dirty="0"/>
-            </a:br>
-            <a:r>
-              <a:rPr lang="sk-SK" dirty="0"/>
-              <a:t>- Existujú aj alternatívne prístupy založené na porovnávaní </a:t>
-            </a:r>
-            <a:r>
-              <a:rPr lang="sk-SK" dirty="0" err="1"/>
-              <a:t>embeddingov</a:t>
-            </a:r>
-            <a:br>
-              <a:rPr lang="sk-SK" dirty="0"/>
-            </a:br>
-            <a:r>
-              <a:rPr lang="sk-SK" dirty="0"/>
-              <a:t>- Práca skúma možnosť reprezentácie kategórií viacerými vektormi</a:t>
+              <a:t> reprezentácia lepšie zachytí variabilitu objektov v triede</a:t>
             </a:r>
           </a:p>
         </p:txBody>
@@ -5063,10 +5624,10 @@
       </p:grpSpPr>
       <p:sp useBgFill="1">
         <p:nvSpPr>
-          <p:cNvPr id="17" name="Rectangle 16">
+          <p:cNvPr id="1031" name="Rectangle 1030">
             <a:extLst>
               <a:ext uri="{FF2B5EF4-FFF2-40B4-BE49-F238E27FC236}">
-                <a16:creationId xmlns:a16="http://schemas.microsoft.com/office/drawing/2014/main" id="{3741B58E-3B65-4A01-A276-975AB2CF8A08}"/>
+                <a16:creationId xmlns:a16="http://schemas.microsoft.com/office/drawing/2014/main" id="{C33BF9DD-8A45-4EEE-B231-0A14D322E5F9}"/>
               </a:ext>
               <a:ext uri="{C183D7F6-B498-43B3-948B-1728B52AA6E4}">
                 <adec:decorative xmlns:adec="http://schemas.microsoft.com/office/drawing/2017/decorative" val="1"/>
@@ -5087,74 +5648,11 @@
         <p:spPr>
           <a:xfrm>
             <a:off x="0" y="0"/>
-            <a:ext cx="12186315" cy="6858000"/>
+            <a:ext cx="12192001" cy="6334316"/>
           </a:xfrm>
           <a:prstGeom prst="rect">
             <a:avLst/>
           </a:prstGeom>
-          <a:ln>
-            <a:noFill/>
-          </a:ln>
-        </p:spPr>
-        <p:style>
-          <a:lnRef idx="2">
-            <a:schemeClr val="accent6">
-              <a:shade val="50000"/>
-            </a:schemeClr>
-          </a:lnRef>
-          <a:fillRef idx="1001">
-            <a:schemeClr val="lt1"/>
-          </a:fillRef>
-          <a:effectRef idx="0">
-            <a:schemeClr val="accent6"/>
-          </a:effectRef>
-          <a:fontRef idx="minor">
-            <a:schemeClr val="lt1"/>
-          </a:fontRef>
-        </p:style>
-        <p:txBody>
-          <a:bodyPr rtlCol="0" anchor="ctr"/>
-          <a:lstStyle/>
-          <a:p>
-            <a:pPr algn="ctr"/>
-            <a:endParaRPr lang="en-US"/>
-          </a:p>
-        </p:txBody>
-      </p:sp>
-      <p:sp>
-        <p:nvSpPr>
-          <p:cNvPr id="19" name="Rectangle 18">
-            <a:extLst>
-              <a:ext uri="{FF2B5EF4-FFF2-40B4-BE49-F238E27FC236}">
-                <a16:creationId xmlns:a16="http://schemas.microsoft.com/office/drawing/2014/main" id="{7AAC67C3-831B-4AB1-A259-DFB839CAFAFC}"/>
-              </a:ext>
-              <a:ext uri="{C183D7F6-B498-43B3-948B-1728B52AA6E4}">
-                <adec:decorative xmlns:adec="http://schemas.microsoft.com/office/drawing/2017/decorative" val="1"/>
-              </a:ext>
-            </a:extLst>
-          </p:cNvPr>
-          <p:cNvSpPr>
-            <a:spLocks noGrp="1" noRot="1" noChangeAspect="1" noMove="1" noResize="1" noEditPoints="1" noAdjustHandles="1" noChangeArrowheads="1" noChangeShapeType="1" noTextEdit="1"/>
-          </p:cNvSpPr>
-          <p:nvPr>
-            <p:extLst>
-              <p:ext uri="{386F3935-93C4-4BCD-93E2-E3B085C9AB24}">
-                <p16:designElem xmlns:p16="http://schemas.microsoft.com/office/powerpoint/2015/main" val="1"/>
-              </p:ext>
-            </p:extLst>
-          </p:nvPr>
-        </p:nvSpPr>
-        <p:spPr>
-          <a:xfrm>
-            <a:off x="16" y="0"/>
-            <a:ext cx="4050791" cy="6858000"/>
-          </a:xfrm>
-          <a:prstGeom prst="rect">
-            <a:avLst/>
-          </a:prstGeom>
-          <a:solidFill>
-            <a:schemeClr val="accent2"/>
-          </a:solidFill>
           <a:ln>
             <a:noFill/>
           </a:ln>
@@ -5176,10 +5674,11 @@
           </a:fontRef>
         </p:style>
         <p:txBody>
-          <a:bodyPr/>
-          <a:lstStyle/>
-          <a:p>
-            <a:endParaRPr lang="sk-SK"/>
+          <a:bodyPr rtlCol="0" anchor="ctr"/>
+          <a:lstStyle/>
+          <a:p>
+            <a:pPr algn="ctr"/>
+            <a:endParaRPr lang="en-US"/>
           </a:p>
         </p:txBody>
       </p:sp>
@@ -5201,172 +5700,37 @@
         </p:nvSpPr>
         <p:spPr>
           <a:xfrm>
-            <a:off x="492370" y="605896"/>
-            <a:ext cx="3084844" cy="5646208"/>
-          </a:xfrm>
-        </p:spPr>
-        <p:txBody>
-          <a:bodyPr anchor="ctr">
+            <a:off x="4974770" y="1341847"/>
+            <a:ext cx="6574972" cy="636489"/>
+          </a:xfrm>
+        </p:spPr>
+        <p:txBody>
+          <a:bodyPr>
             <a:normAutofit/>
           </a:bodyPr>
           <a:lstStyle/>
           <a:p>
             <a:r>
-              <a:rPr lang="sk-SK" sz="3600">
-                <a:solidFill>
-                  <a:srgbClr val="FFFFFF"/>
-                </a:solidFill>
-              </a:rPr>
-              <a:t>Architektúra Vision Transformeru</a:t>
-            </a:r>
-            <a:br>
-              <a:rPr lang="sk-SK" sz="3600">
-                <a:solidFill>
-                  <a:srgbClr val="FFFFFF"/>
-                </a:solidFill>
-              </a:rPr>
-            </a:br>
-            <a:endParaRPr lang="sk-SK" sz="3600">
-              <a:solidFill>
-                <a:srgbClr val="FFFFFF"/>
-              </a:solidFill>
-            </a:endParaRPr>
-          </a:p>
-        </p:txBody>
-      </p:sp>
-      <p:sp>
-        <p:nvSpPr>
-          <p:cNvPr id="21" name="Rectangle 20">
-            <a:extLst>
-              <a:ext uri="{FF2B5EF4-FFF2-40B4-BE49-F238E27FC236}">
-                <a16:creationId xmlns:a16="http://schemas.microsoft.com/office/drawing/2014/main" id="{054B3F04-9EAC-45C0-B3CE-0387EEA10A0C}"/>
-              </a:ext>
-              <a:ext uri="{C183D7F6-B498-43B3-948B-1728B52AA6E4}">
-                <adec:decorative xmlns:adec="http://schemas.microsoft.com/office/drawing/2017/decorative" val="1"/>
-              </a:ext>
-            </a:extLst>
-          </p:cNvPr>
-          <p:cNvSpPr>
-            <a:spLocks noGrp="1" noRot="1" noChangeAspect="1" noMove="1" noResize="1" noEditPoints="1" noAdjustHandles="1" noChangeArrowheads="1" noChangeShapeType="1" noTextEdit="1"/>
-          </p:cNvSpPr>
-          <p:nvPr>
-            <p:extLst>
-              <p:ext uri="{386F3935-93C4-4BCD-93E2-E3B085C9AB24}">
-                <p16:designElem xmlns:p16="http://schemas.microsoft.com/office/powerpoint/2015/main" val="1"/>
-              </p:ext>
-            </p:extLst>
-          </p:nvPr>
-        </p:nvSpPr>
-        <p:spPr>
-          <a:xfrm>
-            <a:off x="4040071" y="0"/>
-            <a:ext cx="64008" cy="6858000"/>
-          </a:xfrm>
-          <a:prstGeom prst="rect">
-            <a:avLst/>
-          </a:prstGeom>
-          <a:solidFill>
-            <a:schemeClr val="accent1"/>
-          </a:solidFill>
-          <a:ln>
-            <a:noFill/>
-          </a:ln>
-        </p:spPr>
-        <p:style>
-          <a:lnRef idx="2">
-            <a:schemeClr val="accent1">
-              <a:shade val="50000"/>
-            </a:schemeClr>
-          </a:lnRef>
-          <a:fillRef idx="1">
-            <a:schemeClr val="accent1"/>
-          </a:fillRef>
-          <a:effectRef idx="0">
-            <a:schemeClr val="accent1"/>
-          </a:effectRef>
-          <a:fontRef idx="minor">
-            <a:schemeClr val="lt1"/>
-          </a:fontRef>
-        </p:style>
-        <p:txBody>
-          <a:bodyPr/>
-          <a:lstStyle/>
-          <a:p>
-            <a:endParaRPr lang="sk-SK"/>
-          </a:p>
-        </p:txBody>
-      </p:sp>
-      <p:sp>
-        <p:nvSpPr>
-          <p:cNvPr id="3" name="Content Placeholder 2">
-            <a:extLst>
-              <a:ext uri="{FF2B5EF4-FFF2-40B4-BE49-F238E27FC236}">
-                <a16:creationId xmlns:a16="http://schemas.microsoft.com/office/drawing/2014/main" id="{546C7CBA-EBCD-D2B4-458A-AFB98D627B27}"/>
-              </a:ext>
-            </a:extLst>
-          </p:cNvPr>
-          <p:cNvSpPr>
-            <a:spLocks noGrp="1"/>
-          </p:cNvSpPr>
-          <p:nvPr>
-            <p:ph idx="1"/>
-          </p:nvPr>
-        </p:nvSpPr>
-        <p:spPr>
-          <a:xfrm>
-            <a:off x="4742016" y="529580"/>
-            <a:ext cx="6413663" cy="2653498"/>
-          </a:xfrm>
-        </p:spPr>
-        <p:txBody>
-          <a:bodyPr anchor="ctr">
-            <a:normAutofit/>
-          </a:bodyPr>
-          <a:lstStyle/>
-          <a:p>
-            <a:r>
-              <a:rPr lang="sk-SK" dirty="0"/>
-              <a:t>- obraz sa rozdelí na patch-e</a:t>
-            </a:r>
-          </a:p>
-          <a:p>
-            <a:r>
-              <a:rPr lang="sk-SK" dirty="0"/>
-              <a:t>- patch-e sa prevedú na </a:t>
-            </a:r>
-            <a:r>
-              <a:rPr lang="sk-SK" dirty="0" err="1"/>
-              <a:t>embeddingy</a:t>
-            </a:r>
-            <a:endParaRPr lang="sk-SK" dirty="0"/>
-          </a:p>
-          <a:p>
-            <a:r>
-              <a:rPr lang="sk-SK" dirty="0"/>
-              <a:t>- </a:t>
-            </a:r>
-            <a:r>
-              <a:rPr lang="sk-SK" dirty="0" err="1"/>
-              <a:t>transformer</a:t>
-            </a:r>
-            <a:r>
-              <a:rPr lang="sk-SK" dirty="0"/>
+              <a:rPr lang="sk-SK" sz="3600" dirty="0"/>
+              <a:t>Architektúra</a:t>
+            </a:r>
+            <a:r>
+              <a:rPr lang="sk-SK" sz="3700" dirty="0"/>
               <a:t> </a:t>
             </a:r>
             <a:r>
-              <a:rPr lang="sk-SK" dirty="0" err="1"/>
-              <a:t>encoder</a:t>
-            </a:r>
-            <a:r>
-              <a:rPr lang="sk-SK" dirty="0"/>
-              <a:t> spracúva sekvenciu tokenov</a:t>
-            </a:r>
-          </a:p>
-          <a:p>
-            <a:r>
-              <a:rPr lang="sk-SK" dirty="0"/>
-              <a:t>- CLS token reprezentuje celý obraz</a:t>
-            </a:r>
+              <a:rPr lang="sk-SK" sz="3700" dirty="0" err="1"/>
+              <a:t>Vision</a:t>
+            </a:r>
+            <a:r>
+              <a:rPr lang="sk-SK" sz="3700" dirty="0"/>
+              <a:t> </a:t>
+            </a:r>
+            <a:r>
+              <a:rPr lang="sk-SK" sz="3700" dirty="0" err="1"/>
+              <a:t>Transformeru</a:t>
+            </a:r>
+            <a:endParaRPr lang="sk-SK" sz="3700" dirty="0"/>
           </a:p>
         </p:txBody>
       </p:sp>
@@ -5392,15 +5756,14 @@
               </a:ext>
             </a:extLst>
           </a:blip>
-          <a:srcRect/>
           <a:stretch>
             <a:fillRect/>
           </a:stretch>
         </p:blipFill>
         <p:spPr bwMode="auto">
           <a:xfrm>
-            <a:off x="4378221" y="2838574"/>
-            <a:ext cx="6852983" cy="3489846"/>
+            <a:off x="127819" y="2158336"/>
+            <a:ext cx="4903268" cy="2500666"/>
           </a:xfrm>
           <a:prstGeom prst="rect">
             <a:avLst/>
@@ -5417,6 +5780,559 @@
           </a:extLst>
         </p:spPr>
       </p:pic>
+      <p:cxnSp>
+        <p:nvCxnSpPr>
+          <p:cNvPr id="1033" name="Straight Connector 1032">
+            <a:extLst>
+              <a:ext uri="{FF2B5EF4-FFF2-40B4-BE49-F238E27FC236}">
+                <a16:creationId xmlns:a16="http://schemas.microsoft.com/office/drawing/2014/main" id="{9020DCC9-F851-4562-BB20-1AB3C51BFD08}"/>
+              </a:ext>
+              <a:ext uri="{C183D7F6-B498-43B3-948B-1728B52AA6E4}">
+                <adec:decorative xmlns:adec="http://schemas.microsoft.com/office/drawing/2017/decorative" val="1"/>
+              </a:ext>
+            </a:extLst>
+          </p:cNvPr>
+          <p:cNvCxnSpPr>
+            <a:cxnSpLocks noGrp="1" noRot="1" noChangeAspect="1" noMove="1" noResize="1" noEditPoints="1" noAdjustHandles="1" noChangeArrowheads="1" noChangeShapeType="1"/>
+          </p:cNvCxnSpPr>
+          <p:nvPr>
+            <p:extLst>
+              <p:ext uri="{386F3935-93C4-4BCD-93E2-E3B085C9AB24}">
+                <p16:designElem xmlns:p16="http://schemas.microsoft.com/office/powerpoint/2015/main" val="1"/>
+              </p:ext>
+            </p:extLst>
+          </p:nvPr>
+        </p:nvCxnSpPr>
+        <p:spPr>
+          <a:xfrm>
+            <a:off x="4974770" y="2086188"/>
+            <a:ext cx="6089768" cy="0"/>
+          </a:xfrm>
+          <a:prstGeom prst="line">
+            <a:avLst/>
+          </a:prstGeom>
+          <a:ln w="6350">
+            <a:solidFill>
+              <a:schemeClr val="tx1">
+                <a:lumMod val="50000"/>
+                <a:lumOff val="50000"/>
+                <a:alpha val="90000"/>
+              </a:schemeClr>
+            </a:solidFill>
+          </a:ln>
+        </p:spPr>
+        <p:style>
+          <a:lnRef idx="1">
+            <a:schemeClr val="accent1"/>
+          </a:lnRef>
+          <a:fillRef idx="0">
+            <a:schemeClr val="accent1"/>
+          </a:fillRef>
+          <a:effectRef idx="0">
+            <a:schemeClr val="accent1"/>
+          </a:effectRef>
+          <a:fontRef idx="minor">
+            <a:schemeClr val="tx1"/>
+          </a:fontRef>
+        </p:style>
+      </p:cxnSp>
+      <mc:AlternateContent xmlns:mc="http://schemas.openxmlformats.org/markup-compatibility/2006">
+        <mc:Choice xmlns:a14="http://schemas.microsoft.com/office/drawing/2010/main" Requires="a14">
+          <p:sp>
+            <p:nvSpPr>
+              <p:cNvPr id="3" name="Content Placeholder 2">
+                <a:extLst>
+                  <a:ext uri="{FF2B5EF4-FFF2-40B4-BE49-F238E27FC236}">
+                    <a16:creationId xmlns:a16="http://schemas.microsoft.com/office/drawing/2014/main" id="{546C7CBA-EBCD-D2B4-458A-AFB98D627B27}"/>
+                  </a:ext>
+                </a:extLst>
+              </p:cNvPr>
+              <p:cNvSpPr>
+                <a:spLocks noGrp="1"/>
+              </p:cNvSpPr>
+              <p:nvPr>
+                <p:ph idx="1"/>
+              </p:nvPr>
+            </p:nvSpPr>
+            <p:spPr>
+              <a:xfrm>
+                <a:off x="5254200" y="2206936"/>
+                <a:ext cx="6574973" cy="3670180"/>
+              </a:xfrm>
+            </p:spPr>
+            <p:txBody>
+              <a:bodyPr>
+                <a:normAutofit lnSpcReduction="10000"/>
+              </a:bodyPr>
+              <a:lstStyle/>
+              <a:p>
+                <a:pPr>
+                  <a:buFont typeface="Arial" panose="020B0604020202020204" pitchFamily="34" charset="0"/>
+                  <a:buChar char="•"/>
+                </a:pPr>
+                <a:r>
+                  <a:rPr lang="sk-SK" sz="1800" dirty="0"/>
+                  <a:t> </a:t>
+                </a:r>
+                <a:r>
+                  <a:rPr lang="sk-SK" dirty="0"/>
+                  <a:t>obraz sa rozdelí na patch-e</a:t>
+                </a:r>
+              </a:p>
+              <a:p>
+                <a:pPr>
+                  <a:buFont typeface="Arial" panose="020B0604020202020204" pitchFamily="34" charset="0"/>
+                  <a:buChar char="•"/>
+                </a:pPr>
+                <a:r>
+                  <a:rPr lang="sk-SK" dirty="0"/>
+                  <a:t> patch-e sa prevedú na </a:t>
+                </a:r>
+                <a:r>
+                  <a:rPr lang="sk-SK" dirty="0" err="1"/>
+                  <a:t>embeddingy</a:t>
+                </a:r>
+                <a:endParaRPr lang="sk-SK" dirty="0"/>
+              </a:p>
+              <a:p>
+                <a:pPr>
+                  <a:buFont typeface="Arial" panose="020B0604020202020204" pitchFamily="34" charset="0"/>
+                  <a:buChar char="•"/>
+                </a:pPr>
+                <a:r>
+                  <a:rPr lang="sk-SK" dirty="0"/>
+                  <a:t> </a:t>
+                </a:r>
+                <a:r>
+                  <a:rPr lang="sk-SK" dirty="0" err="1"/>
+                  <a:t>transformer</a:t>
+                </a:r>
+                <a:r>
+                  <a:rPr lang="sk-SK" dirty="0"/>
+                  <a:t> </a:t>
+                </a:r>
+                <a:r>
+                  <a:rPr lang="sk-SK" dirty="0" err="1"/>
+                  <a:t>encoder</a:t>
+                </a:r>
+                <a:r>
+                  <a:rPr lang="sk-SK" dirty="0"/>
+                  <a:t> spracúva sekvenciu tokenov</a:t>
+                </a:r>
+              </a:p>
+              <a:p>
+                <a:pPr lvl="1">
+                  <a:buFont typeface="Arial" panose="020B0604020202020204" pitchFamily="34" charset="0"/>
+                  <a:buChar char="•"/>
+                </a:pPr>
+                <a:r>
+                  <a:rPr lang="sk-SK" sz="2000" dirty="0" err="1"/>
+                  <a:t>encoder</a:t>
+                </a:r>
+                <a:r>
+                  <a:rPr lang="sk-SK" sz="2000" dirty="0"/>
+                  <a:t> sa skladá z </a:t>
+                </a:r>
+                <a14:m>
+                  <m:oMath xmlns:m="http://schemas.openxmlformats.org/officeDocument/2006/math">
+                    <m:r>
+                      <a:rPr lang="sk-SK" sz="2000" i="1">
+                        <a:latin typeface="Cambria Math" panose="02040503050406030204" pitchFamily="18" charset="0"/>
+                      </a:rPr>
+                      <m:t>𝑁</m:t>
+                    </m:r>
+                    <m:r>
+                      <a:rPr lang="sk-SK" sz="2000" b="0" i="1" smtClean="0">
+                        <a:latin typeface="Cambria Math" panose="02040503050406030204" pitchFamily="18" charset="0"/>
+                      </a:rPr>
+                      <m:t> </m:t>
+                    </m:r>
+                  </m:oMath>
+                </a14:m>
+                <a:r>
+                  <a:rPr lang="sk-SK" sz="2000" dirty="0"/>
+                  <a:t>identických vrstiev</a:t>
+                </a:r>
+              </a:p>
+              <a:p>
+                <a:pPr lvl="1">
+                  <a:buFont typeface="Arial" panose="020B0604020202020204" pitchFamily="34" charset="0"/>
+                  <a:buChar char="•"/>
+                </a:pPr>
+                <a:r>
+                  <a:rPr lang="sk-SK" sz="2000" dirty="0"/>
+                  <a:t>každá vrstva obsahuje :</a:t>
+                </a:r>
+              </a:p>
+              <a:p>
+                <a:pPr lvl="2">
+                  <a:buFont typeface="Arial" panose="020B0604020202020204" pitchFamily="34" charset="0"/>
+                  <a:buChar char="•"/>
+                </a:pPr>
+                <a:r>
+                  <a:rPr lang="sk-SK" sz="2000" b="1" dirty="0" err="1"/>
+                  <a:t>Multi-Head</a:t>
+                </a:r>
+                <a:r>
+                  <a:rPr lang="sk-SK" sz="2000" b="1" dirty="0"/>
+                  <a:t> </a:t>
+                </a:r>
+                <a:r>
+                  <a:rPr lang="sk-SK" sz="2000" b="1" dirty="0" err="1"/>
+                  <a:t>Self-Attention</a:t>
+                </a:r>
+                <a:endParaRPr lang="sk-SK" sz="2000" b="1" dirty="0"/>
+              </a:p>
+              <a:p>
+                <a:pPr lvl="2">
+                  <a:buFont typeface="Arial" panose="020B0604020202020204" pitchFamily="34" charset="0"/>
+                  <a:buChar char="•"/>
+                </a:pPr>
+                <a:r>
+                  <a:rPr lang="sk-SK" sz="2000" b="1" dirty="0" err="1"/>
+                  <a:t>Feed</a:t>
+                </a:r>
+                <a:r>
+                  <a:rPr lang="sk-SK" sz="2000" b="1" dirty="0"/>
+                  <a:t> Forward </a:t>
+                </a:r>
+                <a:r>
+                  <a:rPr lang="sk-SK" sz="2000" b="1" dirty="0" err="1"/>
+                  <a:t>Network</a:t>
+                </a:r>
+                <a:endParaRPr lang="sk-SK" sz="2000" b="1" dirty="0"/>
+              </a:p>
+              <a:p>
+                <a:pPr lvl="1">
+                  <a:buFont typeface="Arial" panose="020B0604020202020204" pitchFamily="34" charset="0"/>
+                  <a:buChar char="•"/>
+                </a:pPr>
+                <a:r>
+                  <a:rPr lang="en-US" sz="2000" dirty="0"/>
+                  <a:t>residual connection + </a:t>
+                </a:r>
+                <a:r>
+                  <a:rPr lang="en-US" sz="2000" b="1" dirty="0" err="1"/>
+                  <a:t>LayerNorm</a:t>
+                </a:r>
+                <a:r>
+                  <a:rPr lang="en-US" sz="2000" dirty="0"/>
+                  <a:t> po </a:t>
+                </a:r>
+                <a:r>
+                  <a:rPr lang="en-US" sz="2000" dirty="0" err="1"/>
+                  <a:t>každom</a:t>
+                </a:r>
+                <a:r>
+                  <a:rPr lang="en-US" sz="2000" dirty="0"/>
+                  <a:t> </a:t>
+                </a:r>
+                <a:r>
+                  <a:rPr lang="en-US" sz="2000" dirty="0" err="1"/>
+                  <a:t>sublayery</a:t>
+                </a:r>
+                <a:endParaRPr lang="sk-SK" sz="2000" dirty="0"/>
+              </a:p>
+              <a:p>
+                <a:pPr marL="201168" lvl="1" indent="0">
+                  <a:buNone/>
+                </a:pPr>
+                <a:endParaRPr lang="sk-SK" sz="2000" dirty="0"/>
+              </a:p>
+              <a:p>
+                <a:pPr>
+                  <a:buFont typeface="Arial" panose="020B0604020202020204" pitchFamily="34" charset="0"/>
+                  <a:buChar char="•"/>
+                </a:pPr>
+                <a:r>
+                  <a:rPr lang="sk-SK" dirty="0"/>
+                  <a:t> Výstupný </a:t>
+                </a:r>
+                <a:r>
+                  <a:rPr lang="sk-SK" b="1" dirty="0"/>
+                  <a:t>CLS token</a:t>
+                </a:r>
+                <a:r>
+                  <a:rPr lang="sk-SK" dirty="0"/>
+                  <a:t> reprezentuje celý obraz</a:t>
+                </a:r>
+              </a:p>
+            </p:txBody>
+          </p:sp>
+        </mc:Choice>
+        <mc:Fallback>
+          <p:sp>
+            <p:nvSpPr>
+              <p:cNvPr id="3" name="Content Placeholder 2">
+                <a:extLst>
+                  <a:ext uri="{FF2B5EF4-FFF2-40B4-BE49-F238E27FC236}">
+                    <a16:creationId xmlns:a16="http://schemas.microsoft.com/office/drawing/2014/main" id="{546C7CBA-EBCD-D2B4-458A-AFB98D627B27}"/>
+                  </a:ext>
+                </a:extLst>
+              </p:cNvPr>
+              <p:cNvSpPr>
+                <a:spLocks noGrp="1" noRot="1" noChangeAspect="1" noMove="1" noResize="1" noEditPoints="1" noAdjustHandles="1" noChangeArrowheads="1" noChangeShapeType="1" noTextEdit="1"/>
+              </p:cNvSpPr>
+              <p:nvPr>
+                <p:ph idx="1"/>
+              </p:nvPr>
+            </p:nvSpPr>
+            <p:spPr>
+              <a:xfrm>
+                <a:off x="5254200" y="2206936"/>
+                <a:ext cx="6574973" cy="3670180"/>
+              </a:xfrm>
+              <a:blipFill>
+                <a:blip r:embed="rId3"/>
+                <a:stretch>
+                  <a:fillRect l="-2226" t="-2326"/>
+                </a:stretch>
+              </a:blipFill>
+            </p:spPr>
+            <p:txBody>
+              <a:bodyPr/>
+              <a:lstStyle/>
+              <a:p>
+                <a:r>
+                  <a:rPr lang="sk-SK">
+                    <a:noFill/>
+                  </a:rPr>
+                  <a:t> </a:t>
+                </a:r>
+              </a:p>
+            </p:txBody>
+          </p:sp>
+        </mc:Fallback>
+      </mc:AlternateContent>
+      <p:sp>
+        <p:nvSpPr>
+          <p:cNvPr id="1035" name="Rectangle 1034">
+            <a:extLst>
+              <a:ext uri="{FF2B5EF4-FFF2-40B4-BE49-F238E27FC236}">
+                <a16:creationId xmlns:a16="http://schemas.microsoft.com/office/drawing/2014/main" id="{D5FBCAC9-BD8B-4F3B-AD74-EF37D4211349}"/>
+              </a:ext>
+              <a:ext uri="{C183D7F6-B498-43B3-948B-1728B52AA6E4}">
+                <adec:decorative xmlns:adec="http://schemas.microsoft.com/office/drawing/2017/decorative" val="1"/>
+              </a:ext>
+            </a:extLst>
+          </p:cNvPr>
+          <p:cNvSpPr>
+            <a:spLocks noGrp="1" noRot="1" noChangeAspect="1" noMove="1" noResize="1" noEditPoints="1" noAdjustHandles="1" noChangeArrowheads="1" noChangeShapeType="1" noTextEdit="1"/>
+          </p:cNvSpPr>
+          <p:nvPr>
+            <p:extLst>
+              <p:ext uri="{386F3935-93C4-4BCD-93E2-E3B085C9AB24}">
+                <p16:designElem xmlns:p16="http://schemas.microsoft.com/office/powerpoint/2015/main" val="1"/>
+              </p:ext>
+            </p:extLst>
+          </p:nvPr>
+        </p:nvSpPr>
+        <p:spPr>
+          <a:xfrm>
+            <a:off x="15" y="6334316"/>
+            <a:ext cx="12191985" cy="66484"/>
+          </a:xfrm>
+          <a:prstGeom prst="rect">
+            <a:avLst/>
+          </a:prstGeom>
+          <a:solidFill>
+            <a:schemeClr val="accent1"/>
+          </a:solidFill>
+          <a:ln>
+            <a:noFill/>
+          </a:ln>
+        </p:spPr>
+        <p:style>
+          <a:lnRef idx="2">
+            <a:schemeClr val="accent1">
+              <a:shade val="50000"/>
+            </a:schemeClr>
+          </a:lnRef>
+          <a:fillRef idx="1">
+            <a:schemeClr val="accent1"/>
+          </a:fillRef>
+          <a:effectRef idx="0">
+            <a:schemeClr val="accent1"/>
+          </a:effectRef>
+          <a:fontRef idx="minor">
+            <a:schemeClr val="lt1"/>
+          </a:fontRef>
+        </p:style>
+        <p:txBody>
+          <a:bodyPr/>
+          <a:lstStyle/>
+          <a:p>
+            <a:endParaRPr lang="sk-SK"/>
+          </a:p>
+        </p:txBody>
+      </p:sp>
+      <p:sp>
+        <p:nvSpPr>
+          <p:cNvPr id="1042" name="Rectangle 1041">
+            <a:extLst>
+              <a:ext uri="{FF2B5EF4-FFF2-40B4-BE49-F238E27FC236}">
+                <a16:creationId xmlns:a16="http://schemas.microsoft.com/office/drawing/2014/main" id="{9556C5A8-AD7E-4CE7-87BE-9EA3B5E1786F}"/>
+              </a:ext>
+              <a:ext uri="{C183D7F6-B498-43B3-948B-1728B52AA6E4}">
+                <adec:decorative xmlns:adec="http://schemas.microsoft.com/office/drawing/2017/decorative" val="1"/>
+              </a:ext>
+            </a:extLst>
+          </p:cNvPr>
+          <p:cNvSpPr>
+            <a:spLocks noGrp="1" noRot="1" noChangeAspect="1" noMove="1" noResize="1" noEditPoints="1" noAdjustHandles="1" noChangeArrowheads="1" noChangeShapeType="1" noTextEdit="1"/>
+          </p:cNvSpPr>
+          <p:nvPr>
+            <p:extLst>
+              <p:ext uri="{386F3935-93C4-4BCD-93E2-E3B085C9AB24}">
+                <p16:designElem xmlns:p16="http://schemas.microsoft.com/office/powerpoint/2015/main" val="1"/>
+              </p:ext>
+            </p:extLst>
+          </p:nvPr>
+        </p:nvSpPr>
+        <p:spPr>
+          <a:xfrm>
+            <a:off x="1" y="6400800"/>
+            <a:ext cx="12192000" cy="457200"/>
+          </a:xfrm>
+          <a:prstGeom prst="rect">
+            <a:avLst/>
+          </a:prstGeom>
+          <a:solidFill>
+            <a:schemeClr val="accent2"/>
+          </a:solidFill>
+          <a:ln>
+            <a:noFill/>
+          </a:ln>
+        </p:spPr>
+        <p:style>
+          <a:lnRef idx="2">
+            <a:schemeClr val="accent1">
+              <a:shade val="50000"/>
+            </a:schemeClr>
+          </a:lnRef>
+          <a:fillRef idx="1">
+            <a:schemeClr val="accent1"/>
+          </a:fillRef>
+          <a:effectRef idx="0">
+            <a:schemeClr val="accent1"/>
+          </a:effectRef>
+          <a:fontRef idx="minor">
+            <a:schemeClr val="lt1"/>
+          </a:fontRef>
+        </p:style>
+        <p:txBody>
+          <a:bodyPr/>
+          <a:lstStyle/>
+          <a:p>
+            <a:endParaRPr lang="sk-SK"/>
+          </a:p>
+        </p:txBody>
+      </p:sp>
+      <p:pic>
+        <p:nvPicPr>
+          <p:cNvPr id="6" name="Picture 5">
+            <a:extLst>
+              <a:ext uri="{FF2B5EF4-FFF2-40B4-BE49-F238E27FC236}">
+                <a16:creationId xmlns:a16="http://schemas.microsoft.com/office/drawing/2014/main" id="{170D98FC-7AE2-B593-6EB4-85B7713D6C70}"/>
+              </a:ext>
+            </a:extLst>
+          </p:cNvPr>
+          <p:cNvPicPr>
+            <a:picLocks noChangeAspect="1"/>
+          </p:cNvPicPr>
+          <p:nvPr/>
+        </p:nvPicPr>
+        <p:blipFill>
+          <a:blip r:embed="rId4"/>
+          <a:stretch>
+            <a:fillRect/>
+          </a:stretch>
+        </p:blipFill>
+        <p:spPr>
+          <a:xfrm>
+            <a:off x="6690411" y="4950299"/>
+            <a:ext cx="3143689" cy="419158"/>
+          </a:xfrm>
+          <a:prstGeom prst="rect">
+            <a:avLst/>
+          </a:prstGeom>
+        </p:spPr>
+      </p:pic>
+      <p:sp>
+        <p:nvSpPr>
+          <p:cNvPr id="4" name="Rectangle 3">
+            <a:extLst>
+              <a:ext uri="{FF2B5EF4-FFF2-40B4-BE49-F238E27FC236}">
+                <a16:creationId xmlns:a16="http://schemas.microsoft.com/office/drawing/2014/main" id="{6BC08794-9AB9-8A30-4B3F-04023962B0DA}"/>
+              </a:ext>
+            </a:extLst>
+          </p:cNvPr>
+          <p:cNvSpPr/>
+          <p:nvPr/>
+        </p:nvSpPr>
+        <p:spPr>
+          <a:xfrm>
+            <a:off x="127819" y="4659002"/>
+            <a:ext cx="4846951" cy="375114"/>
+          </a:xfrm>
+          <a:prstGeom prst="rect">
+            <a:avLst/>
+          </a:prstGeom>
+          <a:solidFill>
+            <a:schemeClr val="bg1"/>
+          </a:solidFill>
+          <a:ln>
+            <a:noFill/>
+          </a:ln>
+        </p:spPr>
+        <p:style>
+          <a:lnRef idx="2">
+            <a:schemeClr val="accent1">
+              <a:shade val="15000"/>
+            </a:schemeClr>
+          </a:lnRef>
+          <a:fillRef idx="1">
+            <a:schemeClr val="accent1"/>
+          </a:fillRef>
+          <a:effectRef idx="0">
+            <a:schemeClr val="accent1"/>
+          </a:effectRef>
+          <a:fontRef idx="minor">
+            <a:schemeClr val="lt1"/>
+          </a:fontRef>
+        </p:style>
+        <p:txBody>
+          <a:bodyPr rtlCol="0" anchor="ctr"/>
+          <a:lstStyle/>
+          <a:p>
+            <a:pPr algn="ctr"/>
+            <a:r>
+              <a:rPr lang="sk-SK" dirty="0">
+                <a:solidFill>
+                  <a:schemeClr val="tx1"/>
+                </a:solidFill>
+              </a:rPr>
+              <a:t>Zdroj: </a:t>
+            </a:r>
+            <a:r>
+              <a:rPr lang="sk-SK" dirty="0" err="1">
+                <a:solidFill>
+                  <a:schemeClr val="tx1"/>
+                </a:solidFill>
+              </a:rPr>
+              <a:t>Dosovitskiy</a:t>
+            </a:r>
+            <a:r>
+              <a:rPr lang="sk-SK" dirty="0">
+                <a:solidFill>
+                  <a:schemeClr val="tx1"/>
+                </a:solidFill>
+              </a:rPr>
+              <a:t> et al., 2021</a:t>
+            </a:r>
+          </a:p>
+        </p:txBody>
+      </p:sp>
     </p:spTree>
     <p:extLst>
       <p:ext uri="{BB962C8B-B14F-4D97-AF65-F5344CB8AC3E}">
@@ -5433,6 +6349,14 @@
 <file path=ppt/slides/slide4.xml><?xml version="1.0" encoding="utf-8"?>
 <p:sld xmlns:a="http://schemas.openxmlformats.org/drawingml/2006/main" xmlns:r="http://schemas.openxmlformats.org/officeDocument/2006/relationships" xmlns:p="http://schemas.openxmlformats.org/presentationml/2006/main">
   <p:cSld>
+    <p:bg>
+      <p:bgPr>
+        <a:solidFill>
+          <a:schemeClr val="bg1"/>
+        </a:solidFill>
+        <a:effectLst/>
+      </p:bgPr>
+    </p:bg>
     <p:spTree>
       <p:nvGrpSpPr>
         <p:cNvPr id="1" name=""/>
@@ -5447,12 +6371,134 @@
           <a:chExt cx="0" cy="0"/>
         </a:xfrm>
       </p:grpSpPr>
+      <p:sp useBgFill="1">
+        <p:nvSpPr>
+          <p:cNvPr id="8" name="Rectangle 7">
+            <a:extLst>
+              <a:ext uri="{FF2B5EF4-FFF2-40B4-BE49-F238E27FC236}">
+                <a16:creationId xmlns:a16="http://schemas.microsoft.com/office/drawing/2014/main" id="{3741B58E-3B65-4A01-A276-975AB2CF8A08}"/>
+              </a:ext>
+              <a:ext uri="{C183D7F6-B498-43B3-948B-1728B52AA6E4}">
+                <adec:decorative xmlns:adec="http://schemas.microsoft.com/office/drawing/2017/decorative" val="1"/>
+              </a:ext>
+            </a:extLst>
+          </p:cNvPr>
+          <p:cNvSpPr>
+            <a:spLocks noGrp="1" noRot="1" noChangeAspect="1" noMove="1" noResize="1" noEditPoints="1" noAdjustHandles="1" noChangeArrowheads="1" noChangeShapeType="1" noTextEdit="1"/>
+          </p:cNvSpPr>
+          <p:nvPr>
+            <p:extLst>
+              <p:ext uri="{386F3935-93C4-4BCD-93E2-E3B085C9AB24}">
+                <p16:designElem xmlns:p16="http://schemas.microsoft.com/office/powerpoint/2015/main" val="1"/>
+              </p:ext>
+            </p:extLst>
+          </p:nvPr>
+        </p:nvSpPr>
+        <p:spPr>
+          <a:xfrm>
+            <a:off x="0" y="0"/>
+            <a:ext cx="12186315" cy="6858000"/>
+          </a:xfrm>
+          <a:prstGeom prst="rect">
+            <a:avLst/>
+          </a:prstGeom>
+          <a:ln>
+            <a:noFill/>
+          </a:ln>
+        </p:spPr>
+        <p:style>
+          <a:lnRef idx="2">
+            <a:schemeClr val="accent6">
+              <a:shade val="50000"/>
+            </a:schemeClr>
+          </a:lnRef>
+          <a:fillRef idx="1001">
+            <a:schemeClr val="lt1"/>
+          </a:fillRef>
+          <a:effectRef idx="0">
+            <a:schemeClr val="accent6"/>
+          </a:effectRef>
+          <a:fontRef idx="minor">
+            <a:schemeClr val="lt1"/>
+          </a:fontRef>
+        </p:style>
+        <p:txBody>
+          <a:bodyPr rtlCol="0" anchor="ctr"/>
+          <a:lstStyle/>
+          <a:p>
+            <a:pPr algn="ctr"/>
+            <a:endParaRPr lang="en-US"/>
+          </a:p>
+        </p:txBody>
+      </p:sp>
+      <p:sp>
+        <p:nvSpPr>
+          <p:cNvPr id="10" name="Rectangle 9">
+            <a:extLst>
+              <a:ext uri="{FF2B5EF4-FFF2-40B4-BE49-F238E27FC236}">
+                <a16:creationId xmlns:a16="http://schemas.microsoft.com/office/drawing/2014/main" id="{7AAC67C3-831B-4AB1-A259-DFB839CAFAFC}"/>
+              </a:ext>
+              <a:ext uri="{C183D7F6-B498-43B3-948B-1728B52AA6E4}">
+                <adec:decorative xmlns:adec="http://schemas.microsoft.com/office/drawing/2017/decorative" val="1"/>
+              </a:ext>
+            </a:extLst>
+          </p:cNvPr>
+          <p:cNvSpPr>
+            <a:spLocks noGrp="1" noRot="1" noChangeAspect="1" noMove="1" noResize="1" noEditPoints="1" noAdjustHandles="1" noChangeArrowheads="1" noChangeShapeType="1" noTextEdit="1"/>
+          </p:cNvSpPr>
+          <p:nvPr>
+            <p:extLst>
+              <p:ext uri="{386F3935-93C4-4BCD-93E2-E3B085C9AB24}">
+                <p16:designElem xmlns:p16="http://schemas.microsoft.com/office/powerpoint/2015/main" val="1"/>
+              </p:ext>
+            </p:extLst>
+          </p:nvPr>
+        </p:nvSpPr>
+        <p:spPr>
+          <a:xfrm>
+            <a:off x="16" y="0"/>
+            <a:ext cx="4050791" cy="6858000"/>
+          </a:xfrm>
+          <a:prstGeom prst="rect">
+            <a:avLst/>
+          </a:prstGeom>
+          <a:solidFill>
+            <a:schemeClr val="accent2"/>
+          </a:solidFill>
+          <a:ln>
+            <a:noFill/>
+          </a:ln>
+        </p:spPr>
+        <p:style>
+          <a:lnRef idx="2">
+            <a:schemeClr val="accent1">
+              <a:shade val="50000"/>
+            </a:schemeClr>
+          </a:lnRef>
+          <a:fillRef idx="1">
+            <a:schemeClr val="accent1"/>
+          </a:fillRef>
+          <a:effectRef idx="0">
+            <a:schemeClr val="accent1"/>
+          </a:effectRef>
+          <a:fontRef idx="minor">
+            <a:schemeClr val="lt1"/>
+          </a:fontRef>
+        </p:style>
+        <p:txBody>
+          <a:bodyPr/>
+          <a:lstStyle/>
+          <a:p>
+            <a:endParaRPr lang="sk-SK"/>
+          </a:p>
+        </p:txBody>
+      </p:sp>
       <p:sp>
         <p:nvSpPr>
           <p:cNvPr id="2" name="Title 1">
             <a:extLst>
               <a:ext uri="{FF2B5EF4-FFF2-40B4-BE49-F238E27FC236}">
-                <a16:creationId xmlns:a16="http://schemas.microsoft.com/office/drawing/2014/main" id="{2D9AE894-0CDE-FD64-46A4-3B870BB22F6D}"/>
+                <a16:creationId xmlns:a16="http://schemas.microsoft.com/office/drawing/2014/main" id="{3DEDC1AE-7ABE-8E98-C036-7E93825D3F0B}"/>
               </a:ext>
             </a:extLst>
           </p:cNvPr>
@@ -5463,302 +6509,370 @@
             <p:ph type="title"/>
           </p:nvPr>
         </p:nvSpPr>
-        <p:spPr/>
-        <p:txBody>
-          <a:bodyPr/>
-          <a:lstStyle/>
-          <a:p>
-            <a:r>
-              <a:rPr lang="sk-SK" dirty="0"/>
-              <a:t>Prístupy ku klasifikácii</a:t>
-            </a:r>
-          </a:p>
-        </p:txBody>
-      </p:sp>
-      <p:sp>
-        <p:nvSpPr>
-          <p:cNvPr id="4" name="Text Placeholder 3">
+        <p:spPr>
+          <a:xfrm>
+            <a:off x="492370" y="605896"/>
+            <a:ext cx="3084844" cy="5646208"/>
+          </a:xfrm>
+        </p:spPr>
+        <p:txBody>
+          <a:bodyPr anchor="ctr">
+            <a:normAutofit/>
+          </a:bodyPr>
+          <a:lstStyle/>
+          <a:p>
+            <a:r>
+              <a:rPr lang="sk-SK" sz="3600" dirty="0">
+                <a:solidFill>
+                  <a:srgbClr val="FFFFFF"/>
+                </a:solidFill>
+              </a:rPr>
+              <a:t>Vynorenie</a:t>
+            </a:r>
+          </a:p>
+        </p:txBody>
+      </p:sp>
+      <p:sp>
+        <p:nvSpPr>
+          <p:cNvPr id="12" name="Rectangle 11">
             <a:extLst>
               <a:ext uri="{FF2B5EF4-FFF2-40B4-BE49-F238E27FC236}">
-                <a16:creationId xmlns:a16="http://schemas.microsoft.com/office/drawing/2014/main" id="{1FF99398-5A9F-BAC3-1F2A-1399B15AB908}"/>
+                <a16:creationId xmlns:a16="http://schemas.microsoft.com/office/drawing/2014/main" id="{054B3F04-9EAC-45C0-B3CE-0387EEA10A0C}"/>
+              </a:ext>
+              <a:ext uri="{C183D7F6-B498-43B3-948B-1728B52AA6E4}">
+                <adec:decorative xmlns:adec="http://schemas.microsoft.com/office/drawing/2017/decorative" val="1"/>
               </a:ext>
             </a:extLst>
           </p:cNvPr>
           <p:cNvSpPr>
-            <a:spLocks noGrp="1"/>
-          </p:cNvSpPr>
-          <p:nvPr>
-            <p:ph type="body" idx="1"/>
-          </p:nvPr>
-        </p:nvSpPr>
-        <p:spPr>
-          <a:xfrm>
-            <a:off x="1097280" y="1846052"/>
-            <a:ext cx="4937760" cy="736282"/>
-          </a:xfrm>
-          <a:gradFill>
-            <a:gsLst>
-              <a:gs pos="79000">
-                <a:srgbClr val="BD582C"/>
-              </a:gs>
-              <a:gs pos="100000">
-                <a:srgbClr val="E48312"/>
-              </a:gs>
-            </a:gsLst>
-            <a:lin ang="5400000" scaled="1"/>
-          </a:gradFill>
-        </p:spPr>
+            <a:spLocks noGrp="1" noRot="1" noChangeAspect="1" noMove="1" noResize="1" noEditPoints="1" noAdjustHandles="1" noChangeArrowheads="1" noChangeShapeType="1" noTextEdit="1"/>
+          </p:cNvSpPr>
+          <p:nvPr>
+            <p:extLst>
+              <p:ext uri="{386F3935-93C4-4BCD-93E2-E3B085C9AB24}">
+                <p16:designElem xmlns:p16="http://schemas.microsoft.com/office/powerpoint/2015/main" val="1"/>
+              </p:ext>
+            </p:extLst>
+          </p:nvPr>
+        </p:nvSpPr>
+        <p:spPr>
+          <a:xfrm>
+            <a:off x="4040071" y="0"/>
+            <a:ext cx="64008" cy="6858000"/>
+          </a:xfrm>
+          <a:prstGeom prst="rect">
+            <a:avLst/>
+          </a:prstGeom>
+          <a:solidFill>
+            <a:schemeClr val="accent1"/>
+          </a:solidFill>
+          <a:ln>
+            <a:noFill/>
+          </a:ln>
+        </p:spPr>
+        <p:style>
+          <a:lnRef idx="2">
+            <a:schemeClr val="accent1">
+              <a:shade val="50000"/>
+            </a:schemeClr>
+          </a:lnRef>
+          <a:fillRef idx="1">
+            <a:schemeClr val="accent1"/>
+          </a:fillRef>
+          <a:effectRef idx="0">
+            <a:schemeClr val="accent1"/>
+          </a:effectRef>
+          <a:fontRef idx="minor">
+            <a:schemeClr val="lt1"/>
+          </a:fontRef>
+        </p:style>
         <p:txBody>
           <a:bodyPr/>
           <a:lstStyle/>
           <a:p>
-            <a:r>
-              <a:rPr lang="sk-SK" dirty="0">
-                <a:solidFill>
-                  <a:schemeClr val="bg1"/>
-                </a:solidFill>
-              </a:rPr>
-              <a:t>Klasický MLP </a:t>
-            </a:r>
-            <a:r>
-              <a:rPr lang="sk-SK" dirty="0" err="1">
-                <a:solidFill>
-                  <a:schemeClr val="bg1"/>
-                </a:solidFill>
-              </a:rPr>
-              <a:t>head</a:t>
-            </a:r>
-            <a:endParaRPr lang="sk-SK" dirty="0">
-              <a:solidFill>
-                <a:schemeClr val="bg1"/>
-              </a:solidFill>
-            </a:endParaRPr>
-          </a:p>
-        </p:txBody>
-      </p:sp>
-      <p:sp>
-        <p:nvSpPr>
-          <p:cNvPr id="5" name="Content Placeholder 4">
+            <a:endParaRPr lang="sk-SK"/>
+          </a:p>
+        </p:txBody>
+      </p:sp>
+      <mc:AlternateContent xmlns:mc="http://schemas.openxmlformats.org/markup-compatibility/2006" xmlns:a14="http://schemas.microsoft.com/office/drawing/2010/main">
+        <mc:Choice Requires="a14">
+          <p:sp>
+            <p:nvSpPr>
+              <p:cNvPr id="3" name="Content Placeholder 2">
+                <a:extLst>
+                  <a:ext uri="{FF2B5EF4-FFF2-40B4-BE49-F238E27FC236}">
+                    <a16:creationId xmlns:a16="http://schemas.microsoft.com/office/drawing/2014/main" id="{EB69BBE3-A9D9-C72C-1263-0EDDA96FA90A}"/>
+                  </a:ext>
+                </a:extLst>
+              </p:cNvPr>
+              <p:cNvSpPr>
+                <a:spLocks noGrp="1"/>
+              </p:cNvSpPr>
+              <p:nvPr>
+                <p:ph idx="1"/>
+              </p:nvPr>
+            </p:nvSpPr>
+            <p:spPr>
+              <a:xfrm>
+                <a:off x="4742016" y="605896"/>
+                <a:ext cx="6413663" cy="5646208"/>
+              </a:xfrm>
+            </p:spPr>
+            <p:txBody>
+              <a:bodyPr anchor="ctr">
+                <a:normAutofit/>
+              </a:bodyPr>
+              <a:lstStyle/>
+              <a:p>
+                <a:pPr>
+                  <a:buFont typeface="Arial" panose="020B0604020202020204" pitchFamily="34" charset="0"/>
+                  <a:buChar char="•"/>
+                </a:pPr>
+                <a:r>
+                  <a:rPr lang="pl-PL" dirty="0"/>
+                  <a:t> CLS token reprezentuje celý obraz</a:t>
+                </a:r>
+              </a:p>
+              <a:p>
+                <a:pPr>
+                  <a:buFont typeface="Arial" panose="020B0604020202020204" pitchFamily="34" charset="0"/>
+                  <a:buChar char="•"/>
+                </a:pPr>
+                <a:r>
+                  <a:rPr lang="sk-SK" dirty="0"/>
+                  <a:t> klasifikácia založená na podobnosti </a:t>
+                </a:r>
+                <a:r>
+                  <a:rPr lang="sk-SK" dirty="0" err="1"/>
+                  <a:t>embeddingov</a:t>
+                </a:r>
+                <a:endParaRPr lang="sk-SK" dirty="0"/>
+              </a:p>
+              <a:p>
+                <a:pPr>
+                  <a:buFont typeface="Arial" panose="020B0604020202020204" pitchFamily="34" charset="0"/>
+                  <a:buChar char="•"/>
+                </a:pPr>
+                <a:r>
+                  <a:rPr lang="sk-SK" dirty="0"/>
+                  <a:t> CLS token sa porovnáva s reprezentáciami kategórií</a:t>
+                </a:r>
+              </a:p>
+              <a:p>
+                <a:pPr>
+                  <a:buFont typeface="Arial" panose="020B0604020202020204" pitchFamily="34" charset="0"/>
+                  <a:buChar char="•"/>
+                </a:pPr>
+                <a:r>
+                  <a:rPr lang="sk-SK" dirty="0"/>
+                  <a:t> výsledná trieda má najvyššiu </a:t>
+                </a:r>
+                <a:r>
+                  <a:rPr lang="sk-SK" dirty="0" err="1"/>
+                  <a:t>cosine</a:t>
+                </a:r>
+                <a:r>
+                  <a:rPr lang="sk-SK" dirty="0"/>
+                  <a:t> </a:t>
+                </a:r>
+                <a:r>
+                  <a:rPr lang="sk-SK" dirty="0" err="1"/>
+                  <a:t>similarity</a:t>
+                </a:r>
+                <a:endParaRPr lang="sk-SK" dirty="0"/>
+              </a:p>
+              <a:p>
+                <a:pPr>
+                  <a:buFont typeface="Arial" panose="020B0604020202020204" pitchFamily="34" charset="0"/>
+                  <a:buChar char="•"/>
+                </a:pPr>
+                <a:endParaRPr lang="sk-SK" dirty="0"/>
+              </a:p>
+              <a:p>
+                <a:pPr>
+                  <a:buFont typeface="Arial" panose="020B0604020202020204" pitchFamily="34" charset="0"/>
+                  <a:buChar char="•"/>
+                </a:pPr>
+                <a:endParaRPr lang="sk-SK" dirty="0"/>
+              </a:p>
+              <a:p>
+                <a:pPr>
+                  <a:buFont typeface="Arial" panose="020B0604020202020204" pitchFamily="34" charset="0"/>
+                  <a:buChar char="•"/>
+                </a:pPr>
+                <a:endParaRPr lang="sk-SK" dirty="0"/>
+              </a:p>
+              <a:p>
+                <a14:m>
+                  <m:oMath xmlns:m="http://schemas.openxmlformats.org/officeDocument/2006/math">
+                    <m:sSub>
+                      <m:sSubPr>
+                        <m:ctrlPr>
+                          <a:rPr lang="ar-AE" i="1" smtClean="0">
+                            <a:latin typeface="Cambria Math" panose="02040503050406030204" pitchFamily="18" charset="0"/>
+                          </a:rPr>
+                        </m:ctrlPr>
+                      </m:sSubPr>
+                      <m:e>
+                        <m:r>
+                          <a:rPr lang="ar-AE" i="1">
+                            <a:latin typeface="Cambria Math" panose="02040503050406030204" pitchFamily="18" charset="0"/>
+                          </a:rPr>
+                          <m:t>𝑧</m:t>
+                        </m:r>
+                      </m:e>
+                      <m:sub>
+                        <m:r>
+                          <a:rPr lang="ar-AE" i="1">
+                            <a:latin typeface="Cambria Math" panose="02040503050406030204" pitchFamily="18" charset="0"/>
+                          </a:rPr>
+                          <m:t>𝐶𝐿𝑆</m:t>
+                        </m:r>
+                      </m:sub>
+                    </m:sSub>
+                  </m:oMath>
+                </a14:m>
+                <a:r>
+                  <a:rPr lang="sk-SK" dirty="0"/>
+                  <a:t> =</a:t>
+                </a:r>
+                <a:r>
+                  <a:rPr lang="ar-AE" dirty="0"/>
+                  <a:t> </a:t>
+                </a:r>
+                <a:r>
+                  <a:rPr lang="sk-SK" dirty="0"/>
+                  <a:t>reprezentácia obrazu</a:t>
+                </a:r>
+              </a:p>
+              <a:p>
+                <a14:m>
+                  <m:oMath xmlns:m="http://schemas.openxmlformats.org/officeDocument/2006/math">
+                    <m:sSub>
+                      <m:sSubPr>
+                        <m:ctrlPr>
+                          <a:rPr lang="ar-AE" i="1">
+                            <a:latin typeface="Cambria Math" panose="02040503050406030204" pitchFamily="18" charset="0"/>
+                          </a:rPr>
+                        </m:ctrlPr>
+                      </m:sSubPr>
+                      <m:e>
+                        <m:r>
+                          <a:rPr lang="ar-AE" i="1">
+                            <a:latin typeface="Cambria Math" panose="02040503050406030204" pitchFamily="18" charset="0"/>
+                          </a:rPr>
+                          <m:t>𝑐</m:t>
+                        </m:r>
+                      </m:e>
+                      <m:sub>
+                        <m:r>
+                          <a:rPr lang="ar-AE" i="1">
+                            <a:latin typeface="Cambria Math" panose="02040503050406030204" pitchFamily="18" charset="0"/>
+                          </a:rPr>
+                          <m:t>𝑖</m:t>
+                        </m:r>
+                      </m:sub>
+                    </m:sSub>
+                  </m:oMath>
+                </a14:m>
+                <a:r>
+                  <a:rPr lang="ar-AE" dirty="0"/>
+                  <a:t>= </a:t>
+                </a:r>
+                <a:r>
+                  <a:rPr lang="sk-SK" dirty="0"/>
+                  <a:t> </a:t>
+                </a:r>
+                <a:r>
+                  <a:rPr lang="sk-SK" dirty="0" err="1"/>
+                  <a:t>embedding</a:t>
+                </a:r>
+                <a:r>
+                  <a:rPr lang="sk-SK" dirty="0"/>
+                  <a:t> kategórie</a:t>
+                </a:r>
+              </a:p>
+            </p:txBody>
+          </p:sp>
+        </mc:Choice>
+        <mc:Fallback xmlns="">
+          <p:sp>
+            <p:nvSpPr>
+              <p:cNvPr id="3" name="Content Placeholder 2">
+                <a:extLst>
+                  <a:ext uri="{FF2B5EF4-FFF2-40B4-BE49-F238E27FC236}">
+                    <a16:creationId xmlns:a16="http://schemas.microsoft.com/office/drawing/2014/main" id="{EB69BBE3-A9D9-C72C-1263-0EDDA96FA90A}"/>
+                  </a:ext>
+                </a:extLst>
+              </p:cNvPr>
+              <p:cNvSpPr>
+                <a:spLocks noGrp="1" noRot="1" noChangeAspect="1" noMove="1" noResize="1" noEditPoints="1" noAdjustHandles="1" noChangeArrowheads="1" noChangeShapeType="1" noTextEdit="1"/>
+              </p:cNvSpPr>
+              <p:nvPr>
+                <p:ph idx="1"/>
+              </p:nvPr>
+            </p:nvSpPr>
+            <p:spPr>
+              <a:xfrm>
+                <a:off x="4742016" y="605896"/>
+                <a:ext cx="6413663" cy="5646208"/>
+              </a:xfrm>
+              <a:blipFill>
+                <a:blip r:embed="rId2"/>
+                <a:stretch>
+                  <a:fillRect l="-2281"/>
+                </a:stretch>
+              </a:blipFill>
+            </p:spPr>
+            <p:txBody>
+              <a:bodyPr/>
+              <a:lstStyle/>
+              <a:p>
+                <a:r>
+                  <a:rPr lang="sk-SK">
+                    <a:noFill/>
+                  </a:rPr>
+                  <a:t> </a:t>
+                </a:r>
+              </a:p>
+            </p:txBody>
+          </p:sp>
+        </mc:Fallback>
+      </mc:AlternateContent>
+      <p:pic>
+        <p:nvPicPr>
+          <p:cNvPr id="5" name="Picture 4">
             <a:extLst>
               <a:ext uri="{FF2B5EF4-FFF2-40B4-BE49-F238E27FC236}">
-                <a16:creationId xmlns:a16="http://schemas.microsoft.com/office/drawing/2014/main" id="{EB0B848C-E80A-ACBC-E43D-613DC33CDEC1}"/>
+                <a16:creationId xmlns:a16="http://schemas.microsoft.com/office/drawing/2014/main" id="{2B01552A-6E47-2A52-06CA-413F5A5B73C8}"/>
               </a:ext>
             </a:extLst>
           </p:cNvPr>
-          <p:cNvSpPr>
-            <a:spLocks noGrp="1"/>
-          </p:cNvSpPr>
-          <p:nvPr>
-            <p:ph sz="half" idx="2"/>
-          </p:nvPr>
-        </p:nvSpPr>
-        <p:spPr>
-          <a:ln>
-            <a:solidFill>
-              <a:srgbClr val="BD582C"/>
-            </a:solidFill>
-          </a:ln>
-        </p:spPr>
-        <p:txBody>
-          <a:bodyPr/>
-          <a:lstStyle/>
-          <a:p>
-            <a:r>
-              <a:rPr lang="sk-SK" dirty="0"/>
-              <a:t>CLS token → MLP </a:t>
-            </a:r>
-            <a:r>
-              <a:rPr lang="sk-SK" dirty="0" err="1"/>
-              <a:t>head</a:t>
-            </a:r>
-            <a:r>
-              <a:rPr lang="sk-SK" dirty="0"/>
-              <a:t> → </a:t>
-            </a:r>
-            <a:r>
-              <a:rPr lang="sk-SK" dirty="0" err="1"/>
-              <a:t>logits</a:t>
-            </a:r>
-            <a:r>
-              <a:rPr lang="sk-SK" dirty="0"/>
-              <a:t> → </a:t>
-            </a:r>
-            <a:r>
-              <a:rPr lang="sk-SK" dirty="0" err="1"/>
-              <a:t>softmax</a:t>
-            </a:r>
-            <a:endParaRPr lang="sk-SK" dirty="0"/>
-          </a:p>
-          <a:p>
-            <a:endParaRPr lang="sk-SK" dirty="0"/>
-          </a:p>
-          <a:p>
-            <a:r>
-              <a:rPr lang="sk-SK" dirty="0"/>
-              <a:t>- štandardný prístup vo </a:t>
-            </a:r>
-            <a:r>
-              <a:rPr lang="sk-SK" dirty="0" err="1"/>
-              <a:t>Vision</a:t>
-            </a:r>
-            <a:r>
-              <a:rPr lang="sk-SK" dirty="0"/>
-              <a:t> </a:t>
-            </a:r>
-            <a:r>
-              <a:rPr lang="sk-SK" dirty="0" err="1"/>
-              <a:t>Transformeroch</a:t>
-            </a:r>
-            <a:br>
-              <a:rPr lang="sk-SK" dirty="0"/>
-            </a:br>
-            <a:r>
-              <a:rPr lang="sk-SK" dirty="0"/>
-              <a:t>- </a:t>
-            </a:r>
-            <a:r>
-              <a:rPr lang="sk-SK" dirty="0" err="1"/>
-              <a:t>perceptron</a:t>
-            </a:r>
-            <a:r>
-              <a:rPr lang="sk-SK" dirty="0"/>
-              <a:t> vypočítava skóre tried</a:t>
-            </a:r>
-            <a:br>
-              <a:rPr lang="sk-SK" dirty="0"/>
-            </a:br>
-            <a:r>
-              <a:rPr lang="sk-SK" dirty="0"/>
-              <a:t>- výstupom sú pravdepodobnosti kategórií</a:t>
-            </a:r>
-          </a:p>
-        </p:txBody>
-      </p:sp>
-      <p:sp>
-        <p:nvSpPr>
-          <p:cNvPr id="6" name="Text Placeholder 5">
-            <a:extLst>
-              <a:ext uri="{FF2B5EF4-FFF2-40B4-BE49-F238E27FC236}">
-                <a16:creationId xmlns:a16="http://schemas.microsoft.com/office/drawing/2014/main" id="{94B879D7-BCA8-119E-FF2E-D5554D520D57}"/>
-              </a:ext>
-            </a:extLst>
-          </p:cNvPr>
-          <p:cNvSpPr>
-            <a:spLocks noGrp="1"/>
-          </p:cNvSpPr>
-          <p:nvPr>
-            <p:ph type="body" sz="quarter" idx="3"/>
-          </p:nvPr>
-        </p:nvSpPr>
-        <p:spPr>
-          <a:gradFill>
-            <a:gsLst>
-              <a:gs pos="79000">
-                <a:srgbClr val="BD582C"/>
-              </a:gs>
-              <a:gs pos="100000">
-                <a:srgbClr val="E48312"/>
-              </a:gs>
-            </a:gsLst>
-            <a:lin ang="5400000" scaled="1"/>
-          </a:gradFill>
-        </p:spPr>
-        <p:txBody>
-          <a:bodyPr/>
-          <a:lstStyle/>
-          <a:p>
-            <a:r>
-              <a:rPr lang="sk-SK" dirty="0">
-                <a:solidFill>
-                  <a:schemeClr val="bg1"/>
-                </a:solidFill>
-              </a:rPr>
-              <a:t>Vynorenie</a:t>
-            </a:r>
-          </a:p>
-        </p:txBody>
-      </p:sp>
-      <p:sp>
-        <p:nvSpPr>
-          <p:cNvPr id="7" name="Content Placeholder 6">
-            <a:extLst>
-              <a:ext uri="{FF2B5EF4-FFF2-40B4-BE49-F238E27FC236}">
-                <a16:creationId xmlns:a16="http://schemas.microsoft.com/office/drawing/2014/main" id="{0B86B8DC-4F6C-196A-4EFF-E75C11F4159F}"/>
-              </a:ext>
-            </a:extLst>
-          </p:cNvPr>
-          <p:cNvSpPr>
-            <a:spLocks noGrp="1"/>
-          </p:cNvSpPr>
-          <p:nvPr>
-            <p:ph sz="quarter" idx="4"/>
-          </p:nvPr>
-        </p:nvSpPr>
-        <p:spPr>
-          <a:ln>
-            <a:solidFill>
-              <a:srgbClr val="BD582C"/>
-            </a:solidFill>
-          </a:ln>
-        </p:spPr>
-        <p:txBody>
-          <a:bodyPr/>
-          <a:lstStyle/>
-          <a:p>
-            <a:r>
-              <a:rPr lang="sk-SK" dirty="0"/>
-              <a:t>CLS token ↔ reprezentácie kategórií</a:t>
-            </a:r>
-          </a:p>
-          <a:p>
-            <a:endParaRPr lang="sk-SK" dirty="0"/>
-          </a:p>
-          <a:p>
-            <a:r>
-              <a:rPr lang="sk-SK" dirty="0"/>
-              <a:t>- klasifikácia založená na podobnosti </a:t>
-            </a:r>
-            <a:r>
-              <a:rPr lang="sk-SK" dirty="0" err="1"/>
-              <a:t>embeddingov</a:t>
-            </a:r>
-            <a:br>
-              <a:rPr lang="sk-SK" dirty="0"/>
-            </a:br>
-            <a:r>
-              <a:rPr lang="sk-SK" dirty="0"/>
-              <a:t>- CLS token sa porovnáva s reprezentáciami tried</a:t>
-            </a:r>
-            <a:br>
-              <a:rPr lang="sk-SK" dirty="0"/>
-            </a:br>
-            <a:r>
-              <a:rPr lang="sk-SK" dirty="0"/>
-              <a:t>- alternatíva ku klasickému </a:t>
-            </a:r>
-            <a:r>
-              <a:rPr lang="sk-SK" dirty="0" err="1"/>
-              <a:t>classification</a:t>
-            </a:r>
-            <a:r>
-              <a:rPr lang="sk-SK" dirty="0"/>
-              <a:t> </a:t>
-            </a:r>
-            <a:r>
-              <a:rPr lang="sk-SK" dirty="0" err="1"/>
-              <a:t>head</a:t>
-            </a:r>
-            <a:r>
-              <a:rPr lang="sk-SK" dirty="0"/>
-              <a:t> prístupu</a:t>
-            </a:r>
-          </a:p>
-        </p:txBody>
-      </p:sp>
+          <p:cNvPicPr>
+            <a:picLocks noChangeAspect="1"/>
+          </p:cNvPicPr>
+          <p:nvPr/>
+        </p:nvPicPr>
+        <p:blipFill>
+          <a:blip r:embed="rId3"/>
+          <a:stretch>
+            <a:fillRect/>
+          </a:stretch>
+        </p:blipFill>
+        <p:spPr>
+          <a:xfrm>
+            <a:off x="4566936" y="3809554"/>
+            <a:ext cx="2673722" cy="759205"/>
+          </a:xfrm>
+          <a:prstGeom prst="rect">
+            <a:avLst/>
+          </a:prstGeom>
+        </p:spPr>
+      </p:pic>
     </p:spTree>
     <p:extLst>
       <p:ext uri="{BB962C8B-B14F-4D97-AF65-F5344CB8AC3E}">
-        <p14:creationId xmlns:p14="http://schemas.microsoft.com/office/powerpoint/2010/main" val="1857490633"/>
+        <p14:creationId xmlns:p14="http://schemas.microsoft.com/office/powerpoint/2010/main" val="3056888511"/>
       </p:ext>
     </p:extLst>
   </p:cSld>
@@ -5795,7 +6909,7 @@
       </p:grpSpPr>
       <p:sp useBgFill="1">
         <p:nvSpPr>
-          <p:cNvPr id="22" name="Rectangle 21">
+          <p:cNvPr id="8" name="Rectangle 7">
             <a:extLst>
               <a:ext uri="{FF2B5EF4-FFF2-40B4-BE49-F238E27FC236}">
                 <a16:creationId xmlns:a16="http://schemas.microsoft.com/office/drawing/2014/main" id="{3741B58E-3B65-4A01-A276-975AB2CF8A08}"/>
@@ -5855,7 +6969,7 @@
       </p:sp>
       <p:sp>
         <p:nvSpPr>
-          <p:cNvPr id="24" name="Rectangle 23">
+          <p:cNvPr id="10" name="Rectangle 9">
             <a:extLst>
               <a:ext uri="{FF2B5EF4-FFF2-40B4-BE49-F238E27FC236}">
                 <a16:creationId xmlns:a16="http://schemas.microsoft.com/office/drawing/2014/main" id="{7AAC67C3-831B-4AB1-A259-DFB839CAFAFC}"/>
@@ -5917,10 +7031,10 @@
       </p:sp>
       <p:sp>
         <p:nvSpPr>
-          <p:cNvPr id="7" name="Title 6">
+          <p:cNvPr id="2" name="Title 1">
             <a:extLst>
               <a:ext uri="{FF2B5EF4-FFF2-40B4-BE49-F238E27FC236}">
-                <a16:creationId xmlns:a16="http://schemas.microsoft.com/office/drawing/2014/main" id="{136F7BC5-3264-1C65-A150-74E2CC227ADC}"/>
+                <a16:creationId xmlns:a16="http://schemas.microsoft.com/office/drawing/2014/main" id="{19E6C0DE-8BD3-F237-C5E0-3FB93C461522}"/>
               </a:ext>
             </a:extLst>
           </p:cNvPr>
@@ -5944,19 +7058,19 @@
           <a:lstStyle/>
           <a:p>
             <a:r>
-              <a:rPr lang="sk-SK" sz="3600">
+              <a:rPr lang="sk-SK" sz="3600" dirty="0">
                 <a:solidFill>
                   <a:srgbClr val="FFFFFF"/>
                 </a:solidFill>
               </a:rPr>
-              <a:t>Viacvektorové vynorenie kategórií</a:t>
-            </a:r>
-          </a:p>
-        </p:txBody>
-      </p:sp>
-      <p:sp>
-        <p:nvSpPr>
-          <p:cNvPr id="26" name="Rectangle 25">
+              <a:t>Hlava</a:t>
+            </a:r>
+          </a:p>
+        </p:txBody>
+      </p:sp>
+      <p:sp>
+        <p:nvSpPr>
+          <p:cNvPr id="12" name="Rectangle 11">
             <a:extLst>
               <a:ext uri="{FF2B5EF4-FFF2-40B4-BE49-F238E27FC236}">
                 <a16:creationId xmlns:a16="http://schemas.microsoft.com/office/drawing/2014/main" id="{054B3F04-9EAC-45C0-B3CE-0387EEA10A0C}"/>
@@ -6018,10 +7132,10 @@
       </p:sp>
       <p:sp>
         <p:nvSpPr>
-          <p:cNvPr id="8" name="Content Placeholder 7">
+          <p:cNvPr id="3" name="Content Placeholder 2">
             <a:extLst>
               <a:ext uri="{FF2B5EF4-FFF2-40B4-BE49-F238E27FC236}">
-                <a16:creationId xmlns:a16="http://schemas.microsoft.com/office/drawing/2014/main" id="{BED30B49-BAB7-03E8-67E3-3DEC1D6104C5}"/>
+                <a16:creationId xmlns:a16="http://schemas.microsoft.com/office/drawing/2014/main" id="{9CF362D5-9579-48FB-79C3-2FBCC63738BD}"/>
               </a:ext>
             </a:extLst>
           </p:cNvPr>
@@ -6044,48 +7158,93 @@
           </a:bodyPr>
           <a:lstStyle/>
           <a:p>
+            <a:pPr>
+              <a:buFont typeface="Arial" panose="020B0604020202020204" pitchFamily="34" charset="0"/>
+              <a:buChar char="•"/>
+            </a:pPr>
             <a:r>
               <a:rPr lang="sk-SK" dirty="0"/>
-              <a:t>1 kategória → viac reprezentujúcich vektorov</a:t>
-            </a:r>
-          </a:p>
-          <a:p>
+              <a:t> vstupom je výstupný CLS token</a:t>
+            </a:r>
+          </a:p>
+          <a:p>
+            <a:pPr>
+              <a:buFont typeface="Arial" panose="020B0604020202020204" pitchFamily="34" charset="0"/>
+              <a:buChar char="•"/>
+            </a:pPr>
+            <a:r>
+              <a:rPr lang="sk-SK" dirty="0"/>
+              <a:t> </a:t>
+            </a:r>
+            <a:r>
+              <a:rPr lang="sk-SK" dirty="0" err="1"/>
+              <a:t>perceptron</a:t>
+            </a:r>
+            <a:r>
+              <a:rPr lang="sk-SK" dirty="0"/>
+              <a:t> počíta skóre pre každú kategóriu</a:t>
+            </a:r>
+          </a:p>
+          <a:p>
+            <a:pPr>
+              <a:buFont typeface="Arial" panose="020B0604020202020204" pitchFamily="34" charset="0"/>
+              <a:buChar char="•"/>
+            </a:pPr>
+            <a:r>
+              <a:rPr lang="sk-SK" dirty="0"/>
+              <a:t> tieto skóre interpretujeme ako </a:t>
+            </a:r>
+            <a:r>
+              <a:rPr lang="sk-SK" dirty="0" err="1"/>
+              <a:t>logity</a:t>
+            </a:r>
             <a:endParaRPr lang="sk-SK" dirty="0"/>
           </a:p>
           <a:p>
+            <a:pPr>
+              <a:buFont typeface="Arial" panose="020B0604020202020204" pitchFamily="34" charset="0"/>
+              <a:buChar char="•"/>
+            </a:pPr>
             <a:r>
               <a:rPr lang="sk-SK" dirty="0"/>
-              <a:t>- jedna trieda nemusí byť reprezentovaná jediným prototypom</a:t>
-            </a:r>
-            <a:br>
+              <a:t> </a:t>
+            </a:r>
+            <a:r>
+              <a:rPr lang="sk-SK" dirty="0" err="1"/>
+              <a:t>softmax</a:t>
+            </a:r>
+            <a:r>
               <a:rPr lang="sk-SK" dirty="0"/>
-            </a:br>
+              <a:t> prevedie </a:t>
+            </a:r>
+            <a:r>
+              <a:rPr lang="sk-SK" dirty="0" err="1"/>
+              <a:t>logity</a:t>
+            </a:r>
             <a:r>
               <a:rPr lang="sk-SK" dirty="0"/>
-              <a:t>- objekty jednej kategórie môžu mať vysokú variabilitu</a:t>
-            </a:r>
-            <a:br>
+              <a:t> na pravdepodobnosti tried</a:t>
+            </a:r>
+          </a:p>
+          <a:p>
+            <a:pPr>
+              <a:buFont typeface="Arial" panose="020B0604020202020204" pitchFamily="34" charset="0"/>
+              <a:buChar char="•"/>
+            </a:pPr>
+            <a:r>
               <a:rPr lang="sk-SK" dirty="0"/>
-            </a:br>
-            <a:r>
-              <a:rPr lang="sk-SK" dirty="0"/>
-              <a:t>- </a:t>
-            </a:r>
-            <a:r>
-              <a:rPr lang="sk-SK" dirty="0" err="1"/>
-              <a:t>viacvektorová</a:t>
-            </a:r>
-            <a:r>
-              <a:rPr lang="sk-SK" dirty="0"/>
-              <a:t> reprezentácia môže lepšie zachytiť rôzne podoby objektov</a:t>
-            </a:r>
+              <a:t> výsledná kategória má najvyššiu pravdepodobnosť</a:t>
+            </a:r>
+          </a:p>
+          <a:p>
+            <a:endParaRPr lang="sk-SK" dirty="0"/>
           </a:p>
         </p:txBody>
       </p:sp>
     </p:spTree>
     <p:extLst>
       <p:ext uri="{BB962C8B-B14F-4D97-AF65-F5344CB8AC3E}">
-        <p14:creationId xmlns:p14="http://schemas.microsoft.com/office/powerpoint/2010/main" val="3502103679"/>
+        <p14:creationId xmlns:p14="http://schemas.microsoft.com/office/powerpoint/2010/main" val="1962860354"/>
       </p:ext>
     </p:extLst>
   </p:cSld>
@@ -6122,7 +7281,7 @@
       </p:grpSpPr>
       <p:sp useBgFill="1">
         <p:nvSpPr>
-          <p:cNvPr id="8" name="Rectangle 7">
+          <p:cNvPr id="22" name="Rectangle 21">
             <a:extLst>
               <a:ext uri="{FF2B5EF4-FFF2-40B4-BE49-F238E27FC236}">
                 <a16:creationId xmlns:a16="http://schemas.microsoft.com/office/drawing/2014/main" id="{3741B58E-3B65-4A01-A276-975AB2CF8A08}"/>
@@ -6182,7 +7341,7 @@
       </p:sp>
       <p:sp>
         <p:nvSpPr>
-          <p:cNvPr id="10" name="Rectangle 9">
+          <p:cNvPr id="24" name="Rectangle 23">
             <a:extLst>
               <a:ext uri="{FF2B5EF4-FFF2-40B4-BE49-F238E27FC236}">
                 <a16:creationId xmlns:a16="http://schemas.microsoft.com/office/drawing/2014/main" id="{7AAC67C3-831B-4AB1-A259-DFB839CAFAFC}"/>
@@ -6244,10 +7403,10 @@
       </p:sp>
       <p:sp>
         <p:nvSpPr>
-          <p:cNvPr id="2" name="Title 1">
+          <p:cNvPr id="7" name="Title 6">
             <a:extLst>
               <a:ext uri="{FF2B5EF4-FFF2-40B4-BE49-F238E27FC236}">
-                <a16:creationId xmlns:a16="http://schemas.microsoft.com/office/drawing/2014/main" id="{21FFD2D5-9B49-DCEF-282F-C0C8A21DC954}"/>
+                <a16:creationId xmlns:a16="http://schemas.microsoft.com/office/drawing/2014/main" id="{136F7BC5-3264-1C65-A150-74E2CC227ADC}"/>
               </a:ext>
             </a:extLst>
           </p:cNvPr>
@@ -6271,19 +7430,35 @@
           <a:lstStyle/>
           <a:p>
             <a:r>
-              <a:rPr lang="sk-SK" sz="3600">
+              <a:rPr lang="sk-SK" sz="3600" dirty="0">
                 <a:solidFill>
                   <a:srgbClr val="FFFFFF"/>
                 </a:solidFill>
               </a:rPr>
-              <a:t>Aktuálny stav práce</a:t>
-            </a:r>
-          </a:p>
-        </p:txBody>
-      </p:sp>
-      <p:sp>
-        <p:nvSpPr>
-          <p:cNvPr id="12" name="Rectangle 11">
+              <a:t>Experiment: </a:t>
+            </a:r>
+            <a:r>
+              <a:rPr lang="sk-SK" sz="3600" dirty="0" err="1">
+                <a:solidFill>
+                  <a:srgbClr val="FFFFFF"/>
+                </a:solidFill>
+              </a:rPr>
+              <a:t>viacvektorové</a:t>
+            </a:r>
+            <a:r>
+              <a:rPr lang="sk-SK" sz="3600" dirty="0">
+                <a:solidFill>
+                  <a:srgbClr val="FFFFFF"/>
+                </a:solidFill>
+              </a:rPr>
+              <a:t> vynorenie kategórií</a:t>
+            </a:r>
+          </a:p>
+        </p:txBody>
+      </p:sp>
+      <p:sp>
+        <p:nvSpPr>
+          <p:cNvPr id="26" name="Rectangle 25">
             <a:extLst>
               <a:ext uri="{FF2B5EF4-FFF2-40B4-BE49-F238E27FC236}">
                 <a16:creationId xmlns:a16="http://schemas.microsoft.com/office/drawing/2014/main" id="{054B3F04-9EAC-45C0-B3CE-0387EEA10A0C}"/>
@@ -6345,10 +7520,10 @@
       </p:sp>
       <p:sp>
         <p:nvSpPr>
-          <p:cNvPr id="3" name="Content Placeholder 2">
+          <p:cNvPr id="8" name="Content Placeholder 7">
             <a:extLst>
               <a:ext uri="{FF2B5EF4-FFF2-40B4-BE49-F238E27FC236}">
-                <a16:creationId xmlns:a16="http://schemas.microsoft.com/office/drawing/2014/main" id="{02DA9DD0-1E07-B3C3-1233-2F20C13E5D94}"/>
+                <a16:creationId xmlns:a16="http://schemas.microsoft.com/office/drawing/2014/main" id="{BED30B49-BAB7-03E8-67E3-3DEC1D6104C5}"/>
               </a:ext>
             </a:extLst>
           </p:cNvPr>
@@ -6373,77 +7548,48 @@
           <a:p>
             <a:r>
               <a:rPr lang="sk-SK" dirty="0"/>
-              <a:t>- založený </a:t>
+              <a:t>1 kategória → k  </a:t>
             </a:r>
             <a:r>
               <a:rPr lang="sk-SK" dirty="0" err="1"/>
-              <a:t>GitHub</a:t>
+              <a:t>embedding</a:t>
             </a:r>
             <a:r>
               <a:rPr lang="sk-SK" dirty="0"/>
-              <a:t> repozitár  </a:t>
-            </a:r>
-            <a:r>
-              <a:rPr lang="sk-SK" dirty="0">
-                <a:hlinkClick r:id="rId2"/>
-              </a:rPr>
-              <a:t>https://github.com/BushDemon/ViT-prototype-classification</a:t>
-            </a:r>
+              <a:t> vektorov namiesto jedného</a:t>
+            </a:r>
+          </a:p>
+          <a:p>
+            <a:endParaRPr lang="sk-SK" dirty="0"/>
+          </a:p>
+          <a:p>
+            <a:pPr>
+              <a:buFont typeface="Arial" panose="020B0604020202020204" pitchFamily="34" charset="0"/>
+              <a:buChar char="•"/>
+            </a:pPr>
             <a:r>
               <a:rPr lang="sk-SK" dirty="0"/>
-              <a:t> </a:t>
-            </a:r>
-            <a:br>
+              <a:t> cieľom je rozšíriť klasické vynorenie kategórií</a:t>
+            </a:r>
+          </a:p>
+          <a:p>
+            <a:pPr>
+              <a:buFont typeface="Arial" panose="020B0604020202020204" pitchFamily="34" charset="0"/>
+              <a:buChar char="•"/>
+            </a:pPr>
+            <a:r>
               <a:rPr lang="sk-SK" dirty="0"/>
-            </a:br>
+              <a:t> jedna trieda nebude reprezentovaná jedným vektorom, ale množinou vektorov</a:t>
+            </a:r>
+          </a:p>
+          <a:p>
+            <a:pPr>
+              <a:buFont typeface="Arial" panose="020B0604020202020204" pitchFamily="34" charset="0"/>
+              <a:buChar char="•"/>
+            </a:pPr>
             <a:r>
               <a:rPr lang="sk-SK" dirty="0"/>
-              <a:t>- vytvorená </a:t>
-            </a:r>
-            <a:r>
-              <a:rPr lang="sk-SK" dirty="0" err="1"/>
-              <a:t>LaTeX</a:t>
-            </a:r>
-            <a:r>
-              <a:rPr lang="sk-SK" dirty="0"/>
-              <a:t> kostra diplomovej práce</a:t>
-            </a:r>
-            <a:br>
-              <a:rPr lang="sk-SK" dirty="0"/>
-            </a:br>
-            <a:r>
-              <a:rPr lang="sk-SK" dirty="0"/>
-              <a:t>- pripravené vývojové prostredie</a:t>
-            </a:r>
-            <a:br>
-              <a:rPr lang="sk-SK" dirty="0"/>
-            </a:br>
-            <a:r>
-              <a:rPr lang="sk-SK" dirty="0"/>
-              <a:t>- otestovaný </a:t>
-            </a:r>
-            <a:r>
-              <a:rPr lang="sk-SK" dirty="0" err="1"/>
-              <a:t>framework</a:t>
-            </a:r>
-            <a:r>
-              <a:rPr lang="en-US" dirty="0"/>
-              <a:t>/</a:t>
-            </a:r>
-            <a:r>
-              <a:rPr lang="en-US" dirty="0" err="1"/>
-              <a:t>kni</a:t>
-            </a:r>
-            <a:r>
-              <a:rPr lang="sk-SK" dirty="0"/>
-              <a:t>žnice</a:t>
-            </a:r>
-            <a:br>
-              <a:rPr lang="sk-SK" dirty="0"/>
-            </a:br>
-            <a:r>
-              <a:rPr lang="sk-SK" dirty="0"/>
-              <a:t>- preštudovaná základná literatúra</a:t>
+              <a:t> každý vektor môže zachytávať inú podobu objektu v danej kategórii</a:t>
             </a:r>
           </a:p>
         </p:txBody>
@@ -6451,7 +7597,7 @@
     </p:spTree>
     <p:extLst>
       <p:ext uri="{BB962C8B-B14F-4D97-AF65-F5344CB8AC3E}">
-        <p14:creationId xmlns:p14="http://schemas.microsoft.com/office/powerpoint/2010/main" val="4231944813"/>
+        <p14:creationId xmlns:p14="http://schemas.microsoft.com/office/powerpoint/2010/main" val="3502103679"/>
       </p:ext>
     </p:extLst>
   </p:cSld>
@@ -6464,6 +7610,14 @@
 <file path=ppt/slides/slide7.xml><?xml version="1.0" encoding="utf-8"?>
 <p:sld xmlns:a="http://schemas.openxmlformats.org/drawingml/2006/main" xmlns:r="http://schemas.openxmlformats.org/officeDocument/2006/relationships" xmlns:p="http://schemas.openxmlformats.org/presentationml/2006/main">
   <p:cSld>
+    <p:bg>
+      <p:bgPr>
+        <a:solidFill>
+          <a:schemeClr val="bg1"/>
+        </a:solidFill>
+        <a:effectLst/>
+      </p:bgPr>
+    </p:bg>
     <p:spTree>
       <p:nvGrpSpPr>
         <p:cNvPr id="1" name=""/>
@@ -6478,12 +7632,134 @@
           <a:chExt cx="0" cy="0"/>
         </a:xfrm>
       </p:grpSpPr>
+      <p:sp useBgFill="1">
+        <p:nvSpPr>
+          <p:cNvPr id="8" name="Rectangle 7">
+            <a:extLst>
+              <a:ext uri="{FF2B5EF4-FFF2-40B4-BE49-F238E27FC236}">
+                <a16:creationId xmlns:a16="http://schemas.microsoft.com/office/drawing/2014/main" id="{3741B58E-3B65-4A01-A276-975AB2CF8A08}"/>
+              </a:ext>
+              <a:ext uri="{C183D7F6-B498-43B3-948B-1728B52AA6E4}">
+                <adec:decorative xmlns:adec="http://schemas.microsoft.com/office/drawing/2017/decorative" val="1"/>
+              </a:ext>
+            </a:extLst>
+          </p:cNvPr>
+          <p:cNvSpPr>
+            <a:spLocks noGrp="1" noRot="1" noChangeAspect="1" noMove="1" noResize="1" noEditPoints="1" noAdjustHandles="1" noChangeArrowheads="1" noChangeShapeType="1" noTextEdit="1"/>
+          </p:cNvSpPr>
+          <p:nvPr>
+            <p:extLst>
+              <p:ext uri="{386F3935-93C4-4BCD-93E2-E3B085C9AB24}">
+                <p16:designElem xmlns:p16="http://schemas.microsoft.com/office/powerpoint/2015/main" val="1"/>
+              </p:ext>
+            </p:extLst>
+          </p:nvPr>
+        </p:nvSpPr>
+        <p:spPr>
+          <a:xfrm>
+            <a:off x="0" y="0"/>
+            <a:ext cx="12186315" cy="6858000"/>
+          </a:xfrm>
+          <a:prstGeom prst="rect">
+            <a:avLst/>
+          </a:prstGeom>
+          <a:ln>
+            <a:noFill/>
+          </a:ln>
+        </p:spPr>
+        <p:style>
+          <a:lnRef idx="2">
+            <a:schemeClr val="accent6">
+              <a:shade val="50000"/>
+            </a:schemeClr>
+          </a:lnRef>
+          <a:fillRef idx="1001">
+            <a:schemeClr val="lt1"/>
+          </a:fillRef>
+          <a:effectRef idx="0">
+            <a:schemeClr val="accent6"/>
+          </a:effectRef>
+          <a:fontRef idx="minor">
+            <a:schemeClr val="lt1"/>
+          </a:fontRef>
+        </p:style>
+        <p:txBody>
+          <a:bodyPr rtlCol="0" anchor="ctr"/>
+          <a:lstStyle/>
+          <a:p>
+            <a:pPr algn="ctr"/>
+            <a:endParaRPr lang="en-US"/>
+          </a:p>
+        </p:txBody>
+      </p:sp>
+      <p:sp>
+        <p:nvSpPr>
+          <p:cNvPr id="10" name="Rectangle 9">
+            <a:extLst>
+              <a:ext uri="{FF2B5EF4-FFF2-40B4-BE49-F238E27FC236}">
+                <a16:creationId xmlns:a16="http://schemas.microsoft.com/office/drawing/2014/main" id="{7AAC67C3-831B-4AB1-A259-DFB839CAFAFC}"/>
+              </a:ext>
+              <a:ext uri="{C183D7F6-B498-43B3-948B-1728B52AA6E4}">
+                <adec:decorative xmlns:adec="http://schemas.microsoft.com/office/drawing/2017/decorative" val="1"/>
+              </a:ext>
+            </a:extLst>
+          </p:cNvPr>
+          <p:cNvSpPr>
+            <a:spLocks noGrp="1" noRot="1" noChangeAspect="1" noMove="1" noResize="1" noEditPoints="1" noAdjustHandles="1" noChangeArrowheads="1" noChangeShapeType="1" noTextEdit="1"/>
+          </p:cNvSpPr>
+          <p:nvPr>
+            <p:extLst>
+              <p:ext uri="{386F3935-93C4-4BCD-93E2-E3B085C9AB24}">
+                <p16:designElem xmlns:p16="http://schemas.microsoft.com/office/powerpoint/2015/main" val="1"/>
+              </p:ext>
+            </p:extLst>
+          </p:nvPr>
+        </p:nvSpPr>
+        <p:spPr>
+          <a:xfrm>
+            <a:off x="16" y="0"/>
+            <a:ext cx="4050791" cy="6858000"/>
+          </a:xfrm>
+          <a:prstGeom prst="rect">
+            <a:avLst/>
+          </a:prstGeom>
+          <a:solidFill>
+            <a:schemeClr val="accent2"/>
+          </a:solidFill>
+          <a:ln>
+            <a:noFill/>
+          </a:ln>
+        </p:spPr>
+        <p:style>
+          <a:lnRef idx="2">
+            <a:schemeClr val="accent1">
+              <a:shade val="50000"/>
+            </a:schemeClr>
+          </a:lnRef>
+          <a:fillRef idx="1">
+            <a:schemeClr val="accent1"/>
+          </a:fillRef>
+          <a:effectRef idx="0">
+            <a:schemeClr val="accent1"/>
+          </a:effectRef>
+          <a:fontRef idx="minor">
+            <a:schemeClr val="lt1"/>
+          </a:fontRef>
+        </p:style>
+        <p:txBody>
+          <a:bodyPr/>
+          <a:lstStyle/>
+          <a:p>
+            <a:endParaRPr lang="sk-SK"/>
+          </a:p>
+        </p:txBody>
+      </p:sp>
       <p:sp>
         <p:nvSpPr>
           <p:cNvPr id="2" name="Title 1">
             <a:extLst>
               <a:ext uri="{FF2B5EF4-FFF2-40B4-BE49-F238E27FC236}">
-                <a16:creationId xmlns:a16="http://schemas.microsoft.com/office/drawing/2014/main" id="{21EE4342-B48F-DA65-DC20-0189034BF615}"/>
+                <a16:creationId xmlns:a16="http://schemas.microsoft.com/office/drawing/2014/main" id="{21FFD2D5-9B49-DCEF-282F-C0C8A21DC954}"/>
               </a:ext>
             </a:extLst>
           </p:cNvPr>
@@ -6494,24 +7770,88 @@
             <p:ph type="title"/>
           </p:nvPr>
         </p:nvSpPr>
-        <p:spPr/>
+        <p:spPr>
+          <a:xfrm>
+            <a:off x="492370" y="605896"/>
+            <a:ext cx="3084844" cy="5646208"/>
+          </a:xfrm>
+        </p:spPr>
+        <p:txBody>
+          <a:bodyPr anchor="ctr">
+            <a:normAutofit/>
+          </a:bodyPr>
+          <a:lstStyle/>
+          <a:p>
+            <a:r>
+              <a:rPr lang="sk-SK" sz="3600" dirty="0">
+                <a:solidFill>
+                  <a:srgbClr val="FFFFFF"/>
+                </a:solidFill>
+              </a:rPr>
+              <a:t>Aktuálny stav práce</a:t>
+            </a:r>
+          </a:p>
+        </p:txBody>
+      </p:sp>
+      <p:sp>
+        <p:nvSpPr>
+          <p:cNvPr id="12" name="Rectangle 11">
+            <a:extLst>
+              <a:ext uri="{FF2B5EF4-FFF2-40B4-BE49-F238E27FC236}">
+                <a16:creationId xmlns:a16="http://schemas.microsoft.com/office/drawing/2014/main" id="{054B3F04-9EAC-45C0-B3CE-0387EEA10A0C}"/>
+              </a:ext>
+              <a:ext uri="{C183D7F6-B498-43B3-948B-1728B52AA6E4}">
+                <adec:decorative xmlns:adec="http://schemas.microsoft.com/office/drawing/2017/decorative" val="1"/>
+              </a:ext>
+            </a:extLst>
+          </p:cNvPr>
+          <p:cNvSpPr>
+            <a:spLocks noGrp="1" noRot="1" noChangeAspect="1" noMove="1" noResize="1" noEditPoints="1" noAdjustHandles="1" noChangeArrowheads="1" noChangeShapeType="1" noTextEdit="1"/>
+          </p:cNvSpPr>
+          <p:nvPr>
+            <p:extLst>
+              <p:ext uri="{386F3935-93C4-4BCD-93E2-E3B085C9AB24}">
+                <p16:designElem xmlns:p16="http://schemas.microsoft.com/office/powerpoint/2015/main" val="1"/>
+              </p:ext>
+            </p:extLst>
+          </p:nvPr>
+        </p:nvSpPr>
+        <p:spPr>
+          <a:xfrm>
+            <a:off x="4040071" y="0"/>
+            <a:ext cx="64008" cy="6858000"/>
+          </a:xfrm>
+          <a:prstGeom prst="rect">
+            <a:avLst/>
+          </a:prstGeom>
+          <a:solidFill>
+            <a:schemeClr val="accent1"/>
+          </a:solidFill>
+          <a:ln>
+            <a:noFill/>
+          </a:ln>
+        </p:spPr>
+        <p:style>
+          <a:lnRef idx="2">
+            <a:schemeClr val="accent1">
+              <a:shade val="50000"/>
+            </a:schemeClr>
+          </a:lnRef>
+          <a:fillRef idx="1">
+            <a:schemeClr val="accent1"/>
+          </a:fillRef>
+          <a:effectRef idx="0">
+            <a:schemeClr val="accent1"/>
+          </a:effectRef>
+          <a:fontRef idx="minor">
+            <a:schemeClr val="lt1"/>
+          </a:fontRef>
+        </p:style>
         <p:txBody>
           <a:bodyPr/>
           <a:lstStyle/>
           <a:p>
-            <a:r>
-              <a:rPr lang="sk-SK" dirty="0" err="1"/>
-              <a:t>Github</a:t>
-            </a:r>
-            <a:r>
-              <a:rPr lang="sk-SK" dirty="0"/>
-              <a:t> + </a:t>
-            </a:r>
-            <a:r>
-              <a:rPr lang="sk-SK"/>
-              <a:t>LaTeX</a:t>
-            </a:r>
-            <a:endParaRPr lang="sk-SK" dirty="0"/>
+            <a:endParaRPr lang="sk-SK"/>
           </a:p>
         </p:txBody>
       </p:sp>
@@ -6520,7 +7860,7 @@
           <p:cNvPr id="3" name="Content Placeholder 2">
             <a:extLst>
               <a:ext uri="{FF2B5EF4-FFF2-40B4-BE49-F238E27FC236}">
-                <a16:creationId xmlns:a16="http://schemas.microsoft.com/office/drawing/2014/main" id="{8EEE9B44-DDD0-0240-45E2-A324F950D726}"/>
+                <a16:creationId xmlns:a16="http://schemas.microsoft.com/office/drawing/2014/main" id="{02DA9DD0-1E07-B3C3-1233-2F20C13E5D94}"/>
               </a:ext>
             </a:extLst>
           </p:cNvPr>
@@ -6531,73 +7871,115 @@
             <p:ph idx="1"/>
           </p:nvPr>
         </p:nvSpPr>
-        <p:spPr/>
-        <p:txBody>
-          <a:bodyPr/>
-          <a:lstStyle/>
-          <a:p>
+        <p:spPr>
+          <a:xfrm>
+            <a:off x="4742016" y="605896"/>
+            <a:ext cx="6413663" cy="5646208"/>
+          </a:xfrm>
+        </p:spPr>
+        <p:txBody>
+          <a:bodyPr anchor="ctr">
+            <a:normAutofit/>
+          </a:bodyPr>
+          <a:lstStyle/>
+          <a:p>
+            <a:pPr>
+              <a:buFont typeface="Arial" panose="020B0604020202020204" pitchFamily="34" charset="0"/>
+              <a:buChar char="•"/>
+            </a:pPr>
             <a:r>
               <a:rPr lang="sk-SK" dirty="0"/>
-              <a:t>Štruktúra repozitára</a:t>
-            </a:r>
-          </a:p>
-          <a:p>
-            <a:endParaRPr lang="sk-SK" dirty="0"/>
-          </a:p>
-          <a:p>
-            <a:endParaRPr lang="sk-SK" dirty="0"/>
-          </a:p>
-          <a:p>
-            <a:endParaRPr lang="sk-SK" dirty="0"/>
-          </a:p>
-          <a:p>
-            <a:endParaRPr lang="sk-SK" dirty="0"/>
-          </a:p>
-          <a:p>
-            <a:pPr marL="0" indent="0">
-              <a:buNone/>
+              <a:t> založený </a:t>
+            </a:r>
+            <a:r>
+              <a:rPr lang="sk-SK" dirty="0" err="1"/>
+              <a:t>GitHub</a:t>
+            </a:r>
+            <a:r>
+              <a:rPr lang="sk-SK" dirty="0"/>
+              <a:t> repozitár  </a:t>
+            </a:r>
+            <a:r>
+              <a:rPr lang="sk-SK" dirty="0">
+                <a:hlinkClick r:id="rId2"/>
+              </a:rPr>
+              <a:t>https://github.com/BushDemon/ViT-prototype-classification</a:t>
+            </a:r>
+            <a:r>
+              <a:rPr lang="sk-SK" dirty="0"/>
+              <a:t> </a:t>
+            </a:r>
+          </a:p>
+          <a:p>
+            <a:pPr>
+              <a:buFont typeface="Arial" panose="020B0604020202020204" pitchFamily="34" charset="0"/>
+              <a:buChar char="•"/>
             </a:pPr>
             <a:r>
               <a:rPr lang="sk-SK" dirty="0"/>
-              <a:t>V README.md sa nachádzajú aj ciele a plánované úlohy</a:t>
-            </a:r>
-          </a:p>
-        </p:txBody>
-      </p:sp>
-      <p:pic>
-        <p:nvPicPr>
-          <p:cNvPr id="5" name="Picture 4">
-            <a:extLst>
-              <a:ext uri="{FF2B5EF4-FFF2-40B4-BE49-F238E27FC236}">
-                <a16:creationId xmlns:a16="http://schemas.microsoft.com/office/drawing/2014/main" id="{4F12BD40-03A7-DAF0-C5E0-BC76B0E6E4C4}"/>
-              </a:ext>
-            </a:extLst>
-          </p:cNvPr>
-          <p:cNvPicPr>
-            <a:picLocks noChangeAspect="1"/>
-          </p:cNvPicPr>
-          <p:nvPr/>
-        </p:nvPicPr>
-        <p:blipFill>
-          <a:blip r:embed="rId2"/>
-          <a:stretch>
-            <a:fillRect/>
-          </a:stretch>
-        </p:blipFill>
-        <p:spPr>
-          <a:xfrm>
-            <a:off x="1097280" y="2278931"/>
-            <a:ext cx="5835955" cy="1704232"/>
-          </a:xfrm>
-          <a:prstGeom prst="rect">
-            <a:avLst/>
-          </a:prstGeom>
-        </p:spPr>
-      </p:pic>
+              <a:t> vytvorená </a:t>
+            </a:r>
+            <a:r>
+              <a:rPr lang="sk-SK" dirty="0" err="1"/>
+              <a:t>LaTeX</a:t>
+            </a:r>
+            <a:r>
+              <a:rPr lang="sk-SK" dirty="0"/>
+              <a:t> kostra diplomovej práce</a:t>
+            </a:r>
+          </a:p>
+          <a:p>
+            <a:pPr>
+              <a:buFont typeface="Arial" panose="020B0604020202020204" pitchFamily="34" charset="0"/>
+              <a:buChar char="•"/>
+            </a:pPr>
+            <a:r>
+              <a:rPr lang="sk-SK" dirty="0"/>
+              <a:t> preštudovaná základná literatúra</a:t>
+            </a:r>
+          </a:p>
+          <a:p>
+            <a:pPr>
+              <a:buFont typeface="Arial" panose="020B0604020202020204" pitchFamily="34" charset="0"/>
+              <a:buChar char="•"/>
+            </a:pPr>
+            <a:r>
+              <a:rPr lang="sk-SK" dirty="0"/>
+              <a:t> pripravené vývojové prostredie</a:t>
+            </a:r>
+          </a:p>
+          <a:p>
+            <a:pPr>
+              <a:buFont typeface="Arial" panose="020B0604020202020204" pitchFamily="34" charset="0"/>
+              <a:buChar char="•"/>
+            </a:pPr>
+            <a:r>
+              <a:rPr lang="sk-SK" dirty="0"/>
+              <a:t> otestovaný </a:t>
+            </a:r>
+            <a:r>
+              <a:rPr lang="sk-SK" dirty="0" err="1"/>
+              <a:t>framework</a:t>
+            </a:r>
+            <a:r>
+              <a:rPr lang="en-US" dirty="0"/>
+              <a:t>/</a:t>
+            </a:r>
+            <a:r>
+              <a:rPr lang="en-US" dirty="0" err="1"/>
+              <a:t>kni</a:t>
+            </a:r>
+            <a:r>
+              <a:rPr lang="sk-SK" dirty="0"/>
+              <a:t>žnice</a:t>
+            </a:r>
+          </a:p>
+        </p:txBody>
+      </p:sp>
     </p:spTree>
     <p:extLst>
       <p:ext uri="{BB962C8B-B14F-4D97-AF65-F5344CB8AC3E}">
-        <p14:creationId xmlns:p14="http://schemas.microsoft.com/office/powerpoint/2010/main" val="3734712628"/>
+        <p14:creationId xmlns:p14="http://schemas.microsoft.com/office/powerpoint/2010/main" val="4231944813"/>
       </p:ext>
     </p:extLst>
   </p:cSld>
@@ -6629,7 +8011,7 @@
           <p:cNvPr id="2" name="Title 1">
             <a:extLst>
               <a:ext uri="{FF2B5EF4-FFF2-40B4-BE49-F238E27FC236}">
-                <a16:creationId xmlns:a16="http://schemas.microsoft.com/office/drawing/2014/main" id="{7B1EF07C-36D6-BC87-4879-9FE32ACE4AD8}"/>
+                <a16:creationId xmlns:a16="http://schemas.microsoft.com/office/drawing/2014/main" id="{21EE4342-B48F-DA65-DC20-0189034BF615}"/>
               </a:ext>
             </a:extLst>
           </p:cNvPr>
@@ -6647,12 +8029,17 @@
           <a:p>
             <a:r>
               <a:rPr lang="sk-SK" dirty="0" err="1"/>
-              <a:t>Framework</a:t>
+              <a:t>Github</a:t>
             </a:r>
             <a:r>
               <a:rPr lang="sk-SK" dirty="0"/>
-              <a:t> test</a:t>
-            </a:r>
+              <a:t> + </a:t>
+            </a:r>
+            <a:r>
+              <a:rPr lang="sk-SK"/>
+              <a:t>LaTeX</a:t>
+            </a:r>
+            <a:endParaRPr lang="sk-SK" dirty="0"/>
           </a:p>
         </p:txBody>
       </p:sp>
@@ -6661,7 +8048,7 @@
           <p:cNvPr id="3" name="Content Placeholder 2">
             <a:extLst>
               <a:ext uri="{FF2B5EF4-FFF2-40B4-BE49-F238E27FC236}">
-                <a16:creationId xmlns:a16="http://schemas.microsoft.com/office/drawing/2014/main" id="{252866B2-1E9F-B79C-8561-B0091217EFA4}"/>
+                <a16:creationId xmlns:a16="http://schemas.microsoft.com/office/drawing/2014/main" id="{8EEE9B44-DDD0-0240-45E2-A324F950D726}"/>
               </a:ext>
             </a:extLst>
           </p:cNvPr>
@@ -6679,59 +8066,38 @@
           <a:p>
             <a:r>
               <a:rPr lang="sk-SK" dirty="0"/>
-              <a:t>V mojom teste je použitý </a:t>
-            </a:r>
-            <a:r>
-              <a:rPr lang="sk-SK" dirty="0" err="1"/>
-              <a:t>predtrénovaný</a:t>
-            </a:r>
+              <a:t>Štruktúra repozitára</a:t>
+            </a:r>
+          </a:p>
+          <a:p>
+            <a:endParaRPr lang="sk-SK" dirty="0"/>
+          </a:p>
+          <a:p>
+            <a:endParaRPr lang="sk-SK" dirty="0"/>
+          </a:p>
+          <a:p>
+            <a:endParaRPr lang="sk-SK" dirty="0"/>
+          </a:p>
+          <a:p>
+            <a:endParaRPr lang="sk-SK" dirty="0"/>
+          </a:p>
+          <a:p>
+            <a:pPr marL="0" indent="0">
+              <a:buNone/>
+            </a:pPr>
             <a:r>
               <a:rPr lang="sk-SK" dirty="0"/>
-              <a:t> </a:t>
-            </a:r>
-            <a:r>
-              <a:rPr lang="sk-SK" dirty="0" err="1"/>
-              <a:t>Vision</a:t>
-            </a:r>
-            <a:r>
-              <a:rPr lang="sk-SK" dirty="0"/>
-              <a:t> </a:t>
-            </a:r>
-            <a:r>
-              <a:rPr lang="sk-SK" dirty="0" err="1"/>
-              <a:t>Transformer</a:t>
-            </a:r>
-            <a:r>
-              <a:rPr lang="sk-SK" dirty="0"/>
-              <a:t> vit_b_16 z knižnice </a:t>
-            </a:r>
-            <a:r>
-              <a:rPr lang="sk-SK" dirty="0" err="1"/>
-              <a:t>torchvision</a:t>
-            </a:r>
-            <a:r>
-              <a:rPr lang="sk-SK" dirty="0"/>
-              <a:t>.</a:t>
-            </a:r>
-            <a:br>
-              <a:rPr lang="sk-SK" dirty="0"/>
-            </a:br>
-            <a:r>
-              <a:rPr lang="sk-SK" dirty="0"/>
-              <a:t>Cieľom je overiť načítanie modelu, predspracovanie vstupného obrázka a získanie výstupných pravdepodobností tried.</a:t>
-            </a:r>
-          </a:p>
-          <a:p>
-            <a:endParaRPr lang="sk-SK" dirty="0"/>
+              <a:t>V README.md sa nachádzajú aj ciele a plánované úlohy</a:t>
+            </a:r>
           </a:p>
         </p:txBody>
       </p:sp>
       <p:pic>
         <p:nvPicPr>
-          <p:cNvPr id="9" name="Picture 8">
+          <p:cNvPr id="5" name="Picture 4">
             <a:extLst>
               <a:ext uri="{FF2B5EF4-FFF2-40B4-BE49-F238E27FC236}">
-                <a16:creationId xmlns:a16="http://schemas.microsoft.com/office/drawing/2014/main" id="{2453C978-CEB6-C737-7668-FAE005FA9ACE}"/>
+                <a16:creationId xmlns:a16="http://schemas.microsoft.com/office/drawing/2014/main" id="{4F12BD40-03A7-DAF0-C5E0-BC76B0E6E4C4}"/>
               </a:ext>
             </a:extLst>
           </p:cNvPr>
@@ -6748,38 +8114,8 @@
         </p:blipFill>
         <p:spPr>
           <a:xfrm>
-            <a:off x="1097280" y="2746094"/>
-            <a:ext cx="4551103" cy="3478192"/>
-          </a:xfrm>
-          <a:prstGeom prst="rect">
-            <a:avLst/>
-          </a:prstGeom>
-        </p:spPr>
-      </p:pic>
-      <p:pic>
-        <p:nvPicPr>
-          <p:cNvPr id="11" name="Picture 10">
-            <a:extLst>
-              <a:ext uri="{FF2B5EF4-FFF2-40B4-BE49-F238E27FC236}">
-                <a16:creationId xmlns:a16="http://schemas.microsoft.com/office/drawing/2014/main" id="{E67D4B07-56A4-806D-8F09-6E106BB28963}"/>
-              </a:ext>
-            </a:extLst>
-          </p:cNvPr>
-          <p:cNvPicPr>
-            <a:picLocks noChangeAspect="1"/>
-          </p:cNvPicPr>
-          <p:nvPr/>
-        </p:nvPicPr>
-        <p:blipFill>
-          <a:blip r:embed="rId3"/>
-          <a:stretch>
-            <a:fillRect/>
-          </a:stretch>
-        </p:blipFill>
-        <p:spPr>
-          <a:xfrm>
-            <a:off x="5690824" y="2746094"/>
-            <a:ext cx="4219437" cy="2138422"/>
+            <a:off x="1097280" y="2278931"/>
+            <a:ext cx="5835955" cy="1704232"/>
           </a:xfrm>
           <a:prstGeom prst="rect">
             <a:avLst/>
@@ -6789,7 +8125,7 @@
     </p:spTree>
     <p:extLst>
       <p:ext uri="{BB962C8B-B14F-4D97-AF65-F5344CB8AC3E}">
-        <p14:creationId xmlns:p14="http://schemas.microsoft.com/office/powerpoint/2010/main" val="2086404062"/>
+        <p14:creationId xmlns:p14="http://schemas.microsoft.com/office/powerpoint/2010/main" val="3734712628"/>
       </p:ext>
     </p:extLst>
   </p:cSld>
@@ -6802,14 +8138,6 @@
 <file path=ppt/slides/slide9.xml><?xml version="1.0" encoding="utf-8"?>
 <p:sld xmlns:a="http://schemas.openxmlformats.org/drawingml/2006/main" xmlns:r="http://schemas.openxmlformats.org/officeDocument/2006/relationships" xmlns:p="http://schemas.openxmlformats.org/presentationml/2006/main">
   <p:cSld>
-    <p:bg>
-      <p:bgPr>
-        <a:solidFill>
-          <a:schemeClr val="bg1"/>
-        </a:solidFill>
-        <a:effectLst/>
-      </p:bgPr>
-    </p:bg>
     <p:spTree>
       <p:nvGrpSpPr>
         <p:cNvPr id="1" name=""/>
@@ -6824,134 +8152,130 @@
           <a:chExt cx="0" cy="0"/>
         </a:xfrm>
       </p:grpSpPr>
-      <p:sp useBgFill="1">
-        <p:nvSpPr>
-          <p:cNvPr id="17" name="Rectangle 16">
+      <p:sp>
+        <p:nvSpPr>
+          <p:cNvPr id="4" name="Title 3">
             <a:extLst>
               <a:ext uri="{FF2B5EF4-FFF2-40B4-BE49-F238E27FC236}">
-                <a16:creationId xmlns:a16="http://schemas.microsoft.com/office/drawing/2014/main" id="{3741B58E-3B65-4A01-A276-975AB2CF8A08}"/>
-              </a:ext>
-              <a:ext uri="{C183D7F6-B498-43B3-948B-1728B52AA6E4}">
-                <adec:decorative xmlns:adec="http://schemas.microsoft.com/office/drawing/2017/decorative" val="1"/>
+                <a16:creationId xmlns:a16="http://schemas.microsoft.com/office/drawing/2014/main" id="{663EE4F3-7F0A-41F6-4A0D-5BFF58D3CEFF}"/>
               </a:ext>
             </a:extLst>
           </p:cNvPr>
           <p:cNvSpPr>
-            <a:spLocks noGrp="1" noRot="1" noChangeAspect="1" noMove="1" noResize="1" noEditPoints="1" noAdjustHandles="1" noChangeArrowheads="1" noChangeShapeType="1" noTextEdit="1"/>
-          </p:cNvSpPr>
-          <p:nvPr>
-            <p:extLst>
-              <p:ext uri="{386F3935-93C4-4BCD-93E2-E3B085C9AB24}">
-                <p16:designElem xmlns:p16="http://schemas.microsoft.com/office/powerpoint/2015/main" val="1"/>
-              </p:ext>
-            </p:extLst>
-          </p:nvPr>
-        </p:nvSpPr>
-        <p:spPr>
-          <a:xfrm>
-            <a:off x="0" y="0"/>
-            <a:ext cx="12186315" cy="6858000"/>
-          </a:xfrm>
-          <a:prstGeom prst="rect">
-            <a:avLst/>
-          </a:prstGeom>
-          <a:ln>
-            <a:noFill/>
-          </a:ln>
-        </p:spPr>
-        <p:style>
-          <a:lnRef idx="2">
-            <a:schemeClr val="accent6">
-              <a:shade val="50000"/>
-            </a:schemeClr>
-          </a:lnRef>
-          <a:fillRef idx="1001">
-            <a:schemeClr val="lt1"/>
-          </a:fillRef>
-          <a:effectRef idx="0">
-            <a:schemeClr val="accent6"/>
-          </a:effectRef>
-          <a:fontRef idx="minor">
-            <a:schemeClr val="lt1"/>
-          </a:fontRef>
-        </p:style>
-        <p:txBody>
-          <a:bodyPr rtlCol="0" anchor="ctr"/>
-          <a:lstStyle/>
-          <a:p>
-            <a:pPr algn="ctr"/>
-            <a:endParaRPr lang="en-US"/>
-          </a:p>
-        </p:txBody>
-      </p:sp>
-      <p:sp>
-        <p:nvSpPr>
-          <p:cNvPr id="19" name="Rectangle 18">
+            <a:spLocks noGrp="1"/>
+          </p:cNvSpPr>
+          <p:nvPr>
+            <p:ph type="title"/>
+          </p:nvPr>
+        </p:nvSpPr>
+        <p:spPr/>
+        <p:txBody>
+          <a:bodyPr/>
+          <a:lstStyle/>
+          <a:p>
+            <a:r>
+              <a:rPr lang="sk-SK" dirty="0"/>
+              <a:t>Literatúra</a:t>
+            </a:r>
+          </a:p>
+        </p:txBody>
+      </p:sp>
+      <p:sp>
+        <p:nvSpPr>
+          <p:cNvPr id="7" name="Text Placeholder 6">
             <a:extLst>
               <a:ext uri="{FF2B5EF4-FFF2-40B4-BE49-F238E27FC236}">
-                <a16:creationId xmlns:a16="http://schemas.microsoft.com/office/drawing/2014/main" id="{7AAC67C3-831B-4AB1-A259-DFB839CAFAFC}"/>
-              </a:ext>
-              <a:ext uri="{C183D7F6-B498-43B3-948B-1728B52AA6E4}">
-                <adec:decorative xmlns:adec="http://schemas.microsoft.com/office/drawing/2017/decorative" val="1"/>
+                <a16:creationId xmlns:a16="http://schemas.microsoft.com/office/drawing/2014/main" id="{1BB8F1B7-9701-2A73-3648-D5EB763BE225}"/>
               </a:ext>
             </a:extLst>
           </p:cNvPr>
           <p:cNvSpPr>
-            <a:spLocks noGrp="1" noRot="1" noChangeAspect="1" noMove="1" noResize="1" noEditPoints="1" noAdjustHandles="1" noChangeArrowheads="1" noChangeShapeType="1" noTextEdit="1"/>
-          </p:cNvSpPr>
-          <p:nvPr>
-            <p:extLst>
-              <p:ext uri="{386F3935-93C4-4BCD-93E2-E3B085C9AB24}">
-                <p16:designElem xmlns:p16="http://schemas.microsoft.com/office/powerpoint/2015/main" val="1"/>
-              </p:ext>
-            </p:extLst>
-          </p:nvPr>
-        </p:nvSpPr>
-        <p:spPr>
-          <a:xfrm>
-            <a:off x="16" y="0"/>
-            <a:ext cx="4050791" cy="6858000"/>
-          </a:xfrm>
-          <a:prstGeom prst="rect">
-            <a:avLst/>
-          </a:prstGeom>
-          <a:solidFill>
-            <a:schemeClr val="accent2"/>
-          </a:solidFill>
-          <a:ln>
-            <a:noFill/>
-          </a:ln>
-        </p:spPr>
-        <p:style>
-          <a:lnRef idx="2">
-            <a:schemeClr val="accent1">
-              <a:shade val="50000"/>
-            </a:schemeClr>
-          </a:lnRef>
-          <a:fillRef idx="1">
-            <a:schemeClr val="accent1"/>
-          </a:fillRef>
-          <a:effectRef idx="0">
-            <a:schemeClr val="accent1"/>
-          </a:effectRef>
-          <a:fontRef idx="minor">
-            <a:schemeClr val="lt1"/>
-          </a:fontRef>
-        </p:style>
-        <p:txBody>
-          <a:bodyPr/>
-          <a:lstStyle/>
-          <a:p>
-            <a:endParaRPr lang="sk-SK"/>
-          </a:p>
-        </p:txBody>
-      </p:sp>
-      <p:sp>
-        <p:nvSpPr>
-          <p:cNvPr id="2" name="Title 1">
+            <a:spLocks noGrp="1"/>
+          </p:cNvSpPr>
+          <p:nvPr>
+            <p:ph type="body" idx="1"/>
+          </p:nvPr>
+        </p:nvSpPr>
+        <p:spPr/>
+        <p:txBody>
+          <a:bodyPr>
+            <a:normAutofit fontScale="92500" lnSpcReduction="20000"/>
+          </a:bodyPr>
+          <a:lstStyle/>
+          <a:p>
+            <a:r>
+              <a:rPr lang="sk-SK" cap="none" dirty="0">
+                <a:solidFill>
+                  <a:srgbClr val="BD582C"/>
+                </a:solidFill>
+              </a:rPr>
+              <a:t>A</a:t>
+            </a:r>
+            <a:r>
+              <a:rPr lang="en-US" cap="none" dirty="0" err="1">
+                <a:solidFill>
+                  <a:srgbClr val="BD582C"/>
+                </a:solidFill>
+              </a:rPr>
+              <a:t>ttention</a:t>
+            </a:r>
+            <a:r>
+              <a:rPr lang="en-US" cap="none" dirty="0">
+                <a:solidFill>
+                  <a:srgbClr val="BD582C"/>
+                </a:solidFill>
+              </a:rPr>
+              <a:t> </a:t>
+            </a:r>
+            <a:r>
+              <a:rPr lang="sk-SK" cap="none" dirty="0">
+                <a:solidFill>
+                  <a:srgbClr val="BD582C"/>
+                </a:solidFill>
+              </a:rPr>
+              <a:t>i</a:t>
+            </a:r>
+            <a:r>
+              <a:rPr lang="en-US" cap="none" dirty="0">
+                <a:solidFill>
+                  <a:srgbClr val="BD582C"/>
+                </a:solidFill>
+              </a:rPr>
+              <a:t>s All You Need</a:t>
+            </a:r>
+            <a:r>
+              <a:rPr lang="sk-SK" cap="none" dirty="0">
+                <a:solidFill>
+                  <a:srgbClr val="BD582C"/>
+                </a:solidFill>
+              </a:rPr>
+              <a:t> – </a:t>
+            </a:r>
+            <a:r>
+              <a:rPr lang="sk-SK" i="1" cap="none" dirty="0" err="1">
+                <a:solidFill>
+                  <a:srgbClr val="BD582C"/>
+                </a:solidFill>
+              </a:rPr>
+              <a:t>Vaswani</a:t>
+            </a:r>
+            <a:r>
+              <a:rPr lang="sk-SK" i="1" cap="none" dirty="0">
+                <a:solidFill>
+                  <a:srgbClr val="BD582C"/>
+                </a:solidFill>
+              </a:rPr>
+              <a:t> et al.,2017</a:t>
+            </a:r>
+          </a:p>
+        </p:txBody>
+      </p:sp>
+      <p:sp>
+        <p:nvSpPr>
+          <p:cNvPr id="5" name="Content Placeholder 4">
             <a:extLst>
               <a:ext uri="{FF2B5EF4-FFF2-40B4-BE49-F238E27FC236}">
-                <a16:creationId xmlns:a16="http://schemas.microsoft.com/office/drawing/2014/main" id="{D140E1EE-5857-4344-5F2B-F49DA8C5646A}"/>
+                <a16:creationId xmlns:a16="http://schemas.microsoft.com/office/drawing/2014/main" id="{D739A0F4-026D-BDA0-CB18-CA58E44328B8}"/>
               </a:ext>
             </a:extLst>
           </p:cNvPr>
@@ -6959,100 +8283,208 @@
             <a:spLocks noGrp="1"/>
           </p:cNvSpPr>
           <p:nvPr>
-            <p:ph type="title"/>
-          </p:nvPr>
-        </p:nvSpPr>
-        <p:spPr>
-          <a:xfrm>
-            <a:off x="492370" y="605896"/>
-            <a:ext cx="3084844" cy="5646208"/>
-          </a:xfrm>
-        </p:spPr>
-        <p:txBody>
-          <a:bodyPr anchor="ctr">
-            <a:normAutofit/>
-          </a:bodyPr>
-          <a:lstStyle/>
-          <a:p>
-            <a:r>
-              <a:rPr lang="sk-SK" sz="3600">
-                <a:solidFill>
-                  <a:srgbClr val="FFFFFF"/>
-                </a:solidFill>
-              </a:rPr>
-              <a:t>Plán ďalšej práce</a:t>
-            </a:r>
-          </a:p>
-        </p:txBody>
-      </p:sp>
-      <p:sp>
-        <p:nvSpPr>
-          <p:cNvPr id="21" name="Rectangle 20">
+            <p:ph sz="half" idx="2"/>
+          </p:nvPr>
+        </p:nvSpPr>
+        <p:spPr/>
+        <p:txBody>
+          <a:bodyPr/>
+          <a:lstStyle/>
+          <a:p>
+            <a:pPr>
+              <a:buFont typeface="Arial" panose="020B0604020202020204" pitchFamily="34" charset="0"/>
+              <a:buChar char="•"/>
+            </a:pPr>
+            <a:r>
+              <a:rPr lang="sk-SK" dirty="0"/>
+              <a:t> predstavili architektúru </a:t>
+            </a:r>
+            <a:r>
+              <a:rPr lang="sk-SK" b="1" dirty="0" err="1"/>
+              <a:t>Transformer</a:t>
+            </a:r>
+            <a:endParaRPr lang="sk-SK" b="1" dirty="0"/>
+          </a:p>
+          <a:p>
+            <a:pPr>
+              <a:buFont typeface="Arial" panose="020B0604020202020204" pitchFamily="34" charset="0"/>
+              <a:buChar char="•"/>
+            </a:pPr>
+            <a:r>
+              <a:rPr lang="sk-SK" dirty="0"/>
+              <a:t> nahradili </a:t>
+            </a:r>
+            <a:r>
+              <a:rPr lang="sk-SK" dirty="0" err="1"/>
+              <a:t>rekurentné</a:t>
+            </a:r>
+            <a:r>
+              <a:rPr lang="sk-SK" dirty="0"/>
+              <a:t> vrstvy mechanizmom </a:t>
+            </a:r>
+            <a:r>
+              <a:rPr lang="sk-SK" b="1" dirty="0" err="1"/>
+              <a:t>self-attention</a:t>
+            </a:r>
+            <a:endParaRPr lang="sk-SK" b="1" dirty="0"/>
+          </a:p>
+          <a:p>
+            <a:pPr>
+              <a:buFont typeface="Arial" panose="020B0604020202020204" pitchFamily="34" charset="0"/>
+              <a:buChar char="•"/>
+            </a:pPr>
+            <a:r>
+              <a:rPr lang="sk-SK" dirty="0"/>
+              <a:t> zaviedli </a:t>
+            </a:r>
+            <a:r>
+              <a:rPr lang="sk-SK" b="1" dirty="0" err="1"/>
+              <a:t>multi-head</a:t>
+            </a:r>
+            <a:r>
+              <a:rPr lang="sk-SK" b="1" dirty="0"/>
+              <a:t> </a:t>
+            </a:r>
+            <a:r>
+              <a:rPr lang="sk-SK" b="1" dirty="0" err="1"/>
+              <a:t>attention</a:t>
+            </a:r>
+            <a:endParaRPr lang="sk-SK" b="1" dirty="0"/>
+          </a:p>
+          <a:p>
+            <a:pPr>
+              <a:buFont typeface="Arial" panose="020B0604020202020204" pitchFamily="34" charset="0"/>
+              <a:buChar char="•"/>
+            </a:pPr>
+            <a:r>
+              <a:rPr lang="sk-SK" dirty="0"/>
+              <a:t> </a:t>
+            </a:r>
+            <a:r>
+              <a:rPr lang="sk-SK" dirty="0" err="1"/>
+              <a:t>encoder</a:t>
+            </a:r>
+            <a:r>
+              <a:rPr lang="sk-SK" dirty="0"/>
+              <a:t> a </a:t>
+            </a:r>
+            <a:r>
+              <a:rPr lang="sk-SK" dirty="0" err="1"/>
+              <a:t>decoder</a:t>
+            </a:r>
+            <a:r>
+              <a:rPr lang="sk-SK" dirty="0"/>
+              <a:t> sú tvorené opakovaním rovnakých vrstiev</a:t>
+            </a:r>
+          </a:p>
+          <a:p>
+            <a:pPr>
+              <a:buFont typeface="Arial" panose="020B0604020202020204" pitchFamily="34" charset="0"/>
+              <a:buChar char="•"/>
+            </a:pPr>
+            <a:r>
+              <a:rPr lang="sk-SK" dirty="0"/>
+              <a:t> model dosiahol veľmi dobré výsledky v strojovom preklade</a:t>
+            </a:r>
+          </a:p>
+        </p:txBody>
+      </p:sp>
+      <p:sp>
+        <p:nvSpPr>
+          <p:cNvPr id="8" name="Text Placeholder 7">
             <a:extLst>
               <a:ext uri="{FF2B5EF4-FFF2-40B4-BE49-F238E27FC236}">
-                <a16:creationId xmlns:a16="http://schemas.microsoft.com/office/drawing/2014/main" id="{054B3F04-9EAC-45C0-B3CE-0387EEA10A0C}"/>
-              </a:ext>
-              <a:ext uri="{C183D7F6-B498-43B3-948B-1728B52AA6E4}">
-                <adec:decorative xmlns:adec="http://schemas.microsoft.com/office/drawing/2017/decorative" val="1"/>
+                <a16:creationId xmlns:a16="http://schemas.microsoft.com/office/drawing/2014/main" id="{27552689-C05C-F952-3A10-D0F322ED2AE3}"/>
               </a:ext>
             </a:extLst>
           </p:cNvPr>
           <p:cNvSpPr>
-            <a:spLocks noGrp="1" noRot="1" noChangeAspect="1" noMove="1" noResize="1" noEditPoints="1" noAdjustHandles="1" noChangeArrowheads="1" noChangeShapeType="1" noTextEdit="1"/>
-          </p:cNvSpPr>
-          <p:nvPr>
-            <p:extLst>
-              <p:ext uri="{386F3935-93C4-4BCD-93E2-E3B085C9AB24}">
-                <p16:designElem xmlns:p16="http://schemas.microsoft.com/office/powerpoint/2015/main" val="1"/>
-              </p:ext>
-            </p:extLst>
-          </p:nvPr>
-        </p:nvSpPr>
-        <p:spPr>
-          <a:xfrm>
-            <a:off x="4040071" y="0"/>
-            <a:ext cx="64008" cy="6858000"/>
-          </a:xfrm>
-          <a:prstGeom prst="rect">
-            <a:avLst/>
-          </a:prstGeom>
-          <a:solidFill>
-            <a:schemeClr val="accent1"/>
-          </a:solidFill>
-          <a:ln>
-            <a:noFill/>
-          </a:ln>
-        </p:spPr>
-        <p:style>
-          <a:lnRef idx="2">
-            <a:schemeClr val="accent1">
-              <a:shade val="50000"/>
-            </a:schemeClr>
-          </a:lnRef>
-          <a:fillRef idx="1">
-            <a:schemeClr val="accent1"/>
-          </a:fillRef>
-          <a:effectRef idx="0">
-            <a:schemeClr val="accent1"/>
-          </a:effectRef>
-          <a:fontRef idx="minor">
-            <a:schemeClr val="lt1"/>
-          </a:fontRef>
-        </p:style>
-        <p:txBody>
-          <a:bodyPr/>
-          <a:lstStyle/>
-          <a:p>
-            <a:endParaRPr lang="sk-SK"/>
-          </a:p>
-        </p:txBody>
-      </p:sp>
-      <p:sp>
-        <p:nvSpPr>
-          <p:cNvPr id="3" name="Content Placeholder 2">
+            <a:spLocks noGrp="1"/>
+          </p:cNvSpPr>
+          <p:nvPr>
+            <p:ph type="body" sz="quarter" idx="3"/>
+          </p:nvPr>
+        </p:nvSpPr>
+        <p:spPr/>
+        <p:txBody>
+          <a:bodyPr>
+            <a:normAutofit fontScale="92500" lnSpcReduction="20000"/>
+          </a:bodyPr>
+          <a:lstStyle/>
+          <a:p>
+            <a:r>
+              <a:rPr lang="en-US" cap="none" dirty="0">
+                <a:solidFill>
+                  <a:srgbClr val="BD582C"/>
+                </a:solidFill>
+              </a:rPr>
+              <a:t>An Image </a:t>
+            </a:r>
+            <a:r>
+              <a:rPr lang="sk-SK" cap="none" dirty="0">
+                <a:solidFill>
+                  <a:srgbClr val="BD582C"/>
+                </a:solidFill>
+              </a:rPr>
+              <a:t>i</a:t>
+            </a:r>
+            <a:r>
+              <a:rPr lang="en-US" cap="none" dirty="0">
+                <a:solidFill>
+                  <a:srgbClr val="BD582C"/>
+                </a:solidFill>
+              </a:rPr>
+              <a:t>s Worth 16x16 Words</a:t>
+            </a:r>
+            <a:r>
+              <a:rPr lang="sk-SK" cap="none" dirty="0">
+                <a:solidFill>
+                  <a:srgbClr val="BD582C"/>
+                </a:solidFill>
+              </a:rPr>
+              <a:t>: </a:t>
+            </a:r>
+            <a:r>
+              <a:rPr lang="en-US" cap="none" dirty="0">
+                <a:solidFill>
+                  <a:srgbClr val="BD582C"/>
+                </a:solidFill>
+              </a:rPr>
+              <a:t>Transformers For Image Recognition At Scale</a:t>
+            </a:r>
+            <a:r>
+              <a:rPr lang="sk-SK" cap="none" dirty="0">
+                <a:solidFill>
+                  <a:srgbClr val="BD582C"/>
+                </a:solidFill>
+              </a:rPr>
+              <a:t> – </a:t>
+            </a:r>
+            <a:r>
+              <a:rPr lang="sk-SK" cap="none" dirty="0" err="1">
+                <a:solidFill>
+                  <a:srgbClr val="BD582C"/>
+                </a:solidFill>
+              </a:rPr>
+              <a:t>Dosovitskiy</a:t>
+            </a:r>
+            <a:r>
+              <a:rPr lang="sk-SK" cap="none" dirty="0">
+                <a:solidFill>
+                  <a:srgbClr val="BD582C"/>
+                </a:solidFill>
+              </a:rPr>
+              <a:t> et al., 2021</a:t>
+            </a:r>
+          </a:p>
+        </p:txBody>
+      </p:sp>
+      <p:sp>
+        <p:nvSpPr>
+          <p:cNvPr id="9" name="Content Placeholder 8">
             <a:extLst>
               <a:ext uri="{FF2B5EF4-FFF2-40B4-BE49-F238E27FC236}">
-                <a16:creationId xmlns:a16="http://schemas.microsoft.com/office/drawing/2014/main" id="{D671BE1D-4FE4-18E9-93AD-8D9CB704EECA}"/>
+                <a16:creationId xmlns:a16="http://schemas.microsoft.com/office/drawing/2014/main" id="{0EFBB316-A976-71E3-473A-23827501B084}"/>
               </a:ext>
             </a:extLst>
           </p:cNvPr>
@@ -7060,68 +8492,55 @@
             <a:spLocks noGrp="1"/>
           </p:cNvSpPr>
           <p:nvPr>
-            <p:ph idx="1"/>
-          </p:nvPr>
-        </p:nvSpPr>
-        <p:spPr>
-          <a:xfrm>
-            <a:off x="4742016" y="605896"/>
-            <a:ext cx="6413663" cy="5646208"/>
-          </a:xfrm>
-        </p:spPr>
-        <p:txBody>
-          <a:bodyPr anchor="ctr">
-            <a:normAutofit/>
-          </a:bodyPr>
-          <a:lstStyle/>
-          <a:p>
+            <p:ph sz="quarter" idx="4"/>
+          </p:nvPr>
+        </p:nvSpPr>
+        <p:spPr/>
+        <p:txBody>
+          <a:bodyPr/>
+          <a:lstStyle/>
+          <a:p>
+            <a:pPr>
+              <a:buFont typeface="Arial" panose="020B0604020202020204" pitchFamily="34" charset="0"/>
+              <a:buChar char="•"/>
+            </a:pPr>
+            <a:r>
+              <a:rPr lang="pl-PL" dirty="0"/>
+              <a:t> aplikovali Transformer na klasifikáciu obrazu</a:t>
+            </a:r>
+          </a:p>
+          <a:p>
+            <a:pPr>
+              <a:buFont typeface="Arial" panose="020B0604020202020204" pitchFamily="34" charset="0"/>
+              <a:buChar char="•"/>
+            </a:pPr>
+            <a:r>
+              <a:rPr lang="pl-PL" dirty="0"/>
+              <a:t> obraz rozdelili na malé </a:t>
+            </a:r>
+            <a:r>
+              <a:rPr lang="pl-PL" b="1" dirty="0"/>
+              <a:t>patch-e</a:t>
+            </a:r>
+          </a:p>
+          <a:p>
+            <a:pPr>
+              <a:buFont typeface="Arial" panose="020B0604020202020204" pitchFamily="34" charset="0"/>
+              <a:buChar char="•"/>
+            </a:pPr>
             <a:r>
               <a:rPr lang="sk-SK" dirty="0"/>
-              <a:t>- implementácia klasifikácie založenej na vynorení</a:t>
-            </a:r>
-            <a:br>
+              <a:t> patch-e spracovali ako sekvenciu tokenov</a:t>
+            </a:r>
+          </a:p>
+          <a:p>
+            <a:pPr>
+              <a:buFont typeface="Arial" panose="020B0604020202020204" pitchFamily="34" charset="0"/>
+              <a:buChar char="•"/>
+            </a:pPr>
+            <a:r>
               <a:rPr lang="sk-SK" dirty="0"/>
-            </a:br>
-            <a:r>
-              <a:rPr lang="sk-SK" dirty="0"/>
-              <a:t>- implementácia </a:t>
-            </a:r>
-            <a:r>
-              <a:rPr lang="sk-SK" dirty="0" err="1"/>
-              <a:t>viacvektorového</a:t>
-            </a:r>
-            <a:r>
-              <a:rPr lang="sk-SK" dirty="0"/>
-              <a:t> modelu</a:t>
-            </a:r>
-            <a:br>
-              <a:rPr lang="sk-SK" dirty="0"/>
-            </a:br>
-            <a:r>
-              <a:rPr lang="sk-SK" dirty="0"/>
-              <a:t>- návrh experimentov</a:t>
-            </a:r>
-            <a:br>
-              <a:rPr lang="sk-SK" dirty="0"/>
-            </a:br>
-            <a:r>
-              <a:rPr lang="sk-SK" dirty="0"/>
-              <a:t>- porovnanie s </a:t>
-            </a:r>
-            <a:r>
-              <a:rPr lang="sk-SK" dirty="0" err="1"/>
-              <a:t>baseline</a:t>
-            </a:r>
-            <a:r>
-              <a:rPr lang="sk-SK" dirty="0"/>
-              <a:t> modelom</a:t>
-            </a:r>
-            <a:br>
-              <a:rPr lang="sk-SK" dirty="0"/>
-            </a:br>
-            <a:r>
-              <a:rPr lang="sk-SK" dirty="0"/>
-              <a:t>- vyhodnotenie výsledkov</a:t>
+              <a:t> dosiahli konkurencieschopné výsledky bez použitia CNN vrstiev</a:t>
             </a:r>
           </a:p>
         </p:txBody>
@@ -7129,7 +8548,7 @@
     </p:spTree>
     <p:extLst>
       <p:ext uri="{BB962C8B-B14F-4D97-AF65-F5344CB8AC3E}">
-        <p14:creationId xmlns:p14="http://schemas.microsoft.com/office/powerpoint/2010/main" val="2473980231"/>
+        <p14:creationId xmlns:p14="http://schemas.microsoft.com/office/powerpoint/2010/main" val="1501026426"/>
       </p:ext>
     </p:extLst>
   </p:cSld>

</xml_diff>